<commit_message>
Laid out the structure of the poster, moving on to implementing QR codes for refs and asset licenses / github repository link
</commit_message>
<xml_diff>
--- a/30077548ProjectPoster.pptx
+++ b/30077548ProjectPoster.pptx
@@ -104,6 +104,11 @@
       </a:defRPr>
     </a:lvl9pPr>
   </p:defaultTextStyle>
+  <p:extLst>
+    <p:ext uri="{EFAFB233-063F-42B5-8137-9DF3F51BA10A}">
+      <p15:sldGuideLst xmlns:p15="http://schemas.microsoft.com/office/powerpoint/2012/main"/>
+    </p:ext>
+  </p:extLst>
 </p:presentation>
 </file>
 
@@ -256,7 +261,7 @@
           <a:p>
             <a:fld id="{2F203B3E-B53B-46D0-941F-66BD0CE762F2}" type="datetimeFigureOut">
               <a:rPr lang="en-GB" smtClean="0"/>
-              <a:t>10/03/2026</a:t>
+              <a:t>13/03/2026</a:t>
             </a:fld>
             <a:endParaRPr lang="en-GB"/>
           </a:p>
@@ -456,7 +461,7 @@
           <a:p>
             <a:fld id="{2F203B3E-B53B-46D0-941F-66BD0CE762F2}" type="datetimeFigureOut">
               <a:rPr lang="en-GB" smtClean="0"/>
-              <a:t>10/03/2026</a:t>
+              <a:t>13/03/2026</a:t>
             </a:fld>
             <a:endParaRPr lang="en-GB"/>
           </a:p>
@@ -666,7 +671,7 @@
           <a:p>
             <a:fld id="{2F203B3E-B53B-46D0-941F-66BD0CE762F2}" type="datetimeFigureOut">
               <a:rPr lang="en-GB" smtClean="0"/>
-              <a:t>10/03/2026</a:t>
+              <a:t>13/03/2026</a:t>
             </a:fld>
             <a:endParaRPr lang="en-GB"/>
           </a:p>
@@ -866,7 +871,7 @@
           <a:p>
             <a:fld id="{2F203B3E-B53B-46D0-941F-66BD0CE762F2}" type="datetimeFigureOut">
               <a:rPr lang="en-GB" smtClean="0"/>
-              <a:t>10/03/2026</a:t>
+              <a:t>13/03/2026</a:t>
             </a:fld>
             <a:endParaRPr lang="en-GB"/>
           </a:p>
@@ -1142,7 +1147,7 @@
           <a:p>
             <a:fld id="{2F203B3E-B53B-46D0-941F-66BD0CE762F2}" type="datetimeFigureOut">
               <a:rPr lang="en-GB" smtClean="0"/>
-              <a:t>10/03/2026</a:t>
+              <a:t>13/03/2026</a:t>
             </a:fld>
             <a:endParaRPr lang="en-GB"/>
           </a:p>
@@ -1410,7 +1415,7 @@
           <a:p>
             <a:fld id="{2F203B3E-B53B-46D0-941F-66BD0CE762F2}" type="datetimeFigureOut">
               <a:rPr lang="en-GB" smtClean="0"/>
-              <a:t>10/03/2026</a:t>
+              <a:t>13/03/2026</a:t>
             </a:fld>
             <a:endParaRPr lang="en-GB"/>
           </a:p>
@@ -1825,7 +1830,7 @@
           <a:p>
             <a:fld id="{2F203B3E-B53B-46D0-941F-66BD0CE762F2}" type="datetimeFigureOut">
               <a:rPr lang="en-GB" smtClean="0"/>
-              <a:t>10/03/2026</a:t>
+              <a:t>13/03/2026</a:t>
             </a:fld>
             <a:endParaRPr lang="en-GB"/>
           </a:p>
@@ -1967,7 +1972,7 @@
           <a:p>
             <a:fld id="{2F203B3E-B53B-46D0-941F-66BD0CE762F2}" type="datetimeFigureOut">
               <a:rPr lang="en-GB" smtClean="0"/>
-              <a:t>10/03/2026</a:t>
+              <a:t>13/03/2026</a:t>
             </a:fld>
             <a:endParaRPr lang="en-GB"/>
           </a:p>
@@ -2080,7 +2085,7 @@
           <a:p>
             <a:fld id="{2F203B3E-B53B-46D0-941F-66BD0CE762F2}" type="datetimeFigureOut">
               <a:rPr lang="en-GB" smtClean="0"/>
-              <a:t>10/03/2026</a:t>
+              <a:t>13/03/2026</a:t>
             </a:fld>
             <a:endParaRPr lang="en-GB"/>
           </a:p>
@@ -2393,7 +2398,7 @@
           <a:p>
             <a:fld id="{2F203B3E-B53B-46D0-941F-66BD0CE762F2}" type="datetimeFigureOut">
               <a:rPr lang="en-GB" smtClean="0"/>
-              <a:t>10/03/2026</a:t>
+              <a:t>13/03/2026</a:t>
             </a:fld>
             <a:endParaRPr lang="en-GB"/>
           </a:p>
@@ -2682,7 +2687,7 @@
           <a:p>
             <a:fld id="{2F203B3E-B53B-46D0-941F-66BD0CE762F2}" type="datetimeFigureOut">
               <a:rPr lang="en-GB" smtClean="0"/>
-              <a:t>10/03/2026</a:t>
+              <a:t>13/03/2026</a:t>
             </a:fld>
             <a:endParaRPr lang="en-GB"/>
           </a:p>
@@ -2925,7 +2930,7 @@
           <a:p>
             <a:fld id="{2F203B3E-B53B-46D0-941F-66BD0CE762F2}" type="datetimeFigureOut">
               <a:rPr lang="en-GB" smtClean="0"/>
-              <a:t>10/03/2026</a:t>
+              <a:t>13/03/2026</a:t>
             </a:fld>
             <a:endParaRPr lang="en-GB"/>
           </a:p>
@@ -3360,26 +3365,19 @@
         </p:nvSpPr>
         <p:spPr>
           <a:xfrm>
-            <a:off x="1889919" y="403466"/>
-            <a:ext cx="11339513" cy="1248871"/>
+            <a:off x="330740" y="302926"/>
+            <a:ext cx="14455303" cy="687930"/>
           </a:xfrm>
         </p:spPr>
         <p:txBody>
           <a:bodyPr>
-            <a:normAutofit fontScale="90000"/>
+            <a:noAutofit/>
           </a:bodyPr>
           <a:lstStyle/>
           <a:p>
             <a:r>
-              <a:rPr lang="en-GB" dirty="0"/>
-              <a:t>30077548 Project Poster</a:t>
-            </a:r>
-            <a:br>
-              <a:rPr lang="en-GB" dirty="0"/>
-            </a:br>
-            <a:r>
-              <a:rPr lang="en-GB" dirty="0"/>
-              <a:t>VR Applications in Ophthalmology</a:t>
+              <a:rPr lang="en-GB" sz="3200" dirty="0"/>
+              <a:t>An Educational Virtual Reality Approach to Raising Awareness of Digital Eye Strain</a:t>
             </a:r>
           </a:p>
         </p:txBody>
@@ -3402,8 +3400,8 @@
         </p:nvSpPr>
         <p:spPr>
           <a:xfrm>
-            <a:off x="1889918" y="1652337"/>
-            <a:ext cx="11339513" cy="687930"/>
+            <a:off x="2520197" y="1146499"/>
+            <a:ext cx="10076387" cy="687930"/>
           </a:xfrm>
         </p:spPr>
         <p:txBody>
@@ -3412,15 +3410,451 @@
           <a:p>
             <a:r>
               <a:rPr lang="en-GB" dirty="0"/>
-              <a:t>30077548 – Sebastian Ha</a:t>
-            </a:r>
-            <a:br>
+              <a:t>Supervisor – Alun King	30077548 – Sebastian Ha	30077548@students.southwales.ac.uk</a:t>
+            </a:r>
+          </a:p>
+        </p:txBody>
+      </p:sp>
+      <p:cxnSp>
+        <p:nvCxnSpPr>
+          <p:cNvPr id="5" name="Straight Connector 4">
+            <a:extLst>
+              <a:ext uri="{FF2B5EF4-FFF2-40B4-BE49-F238E27FC236}">
+                <a16:creationId xmlns:a16="http://schemas.microsoft.com/office/drawing/2014/main" id="{E2D2999B-02E1-D5B3-F30A-EA38B7D8A594}"/>
+              </a:ext>
+            </a:extLst>
+          </p:cNvPr>
+          <p:cNvCxnSpPr/>
+          <p:nvPr/>
+        </p:nvCxnSpPr>
+        <p:spPr>
+          <a:xfrm>
+            <a:off x="505836" y="1834429"/>
+            <a:ext cx="14105107" cy="0"/>
+          </a:xfrm>
+          <a:prstGeom prst="line">
+            <a:avLst/>
+          </a:prstGeom>
+          <a:ln w="76200"/>
+        </p:spPr>
+        <p:style>
+          <a:lnRef idx="2">
+            <a:schemeClr val="dk1"/>
+          </a:lnRef>
+          <a:fillRef idx="0">
+            <a:schemeClr val="dk1"/>
+          </a:fillRef>
+          <a:effectRef idx="1">
+            <a:schemeClr val="dk1"/>
+          </a:effectRef>
+          <a:fontRef idx="minor">
+            <a:schemeClr val="tx1"/>
+          </a:fontRef>
+        </p:style>
+      </p:cxnSp>
+      <p:cxnSp>
+        <p:nvCxnSpPr>
+          <p:cNvPr id="6" name="Straight Connector 5">
+            <a:extLst>
+              <a:ext uri="{FF2B5EF4-FFF2-40B4-BE49-F238E27FC236}">
+                <a16:creationId xmlns:a16="http://schemas.microsoft.com/office/drawing/2014/main" id="{5C714C50-EA7B-FC0B-7D69-98523D9491E4}"/>
+              </a:ext>
+            </a:extLst>
+          </p:cNvPr>
+          <p:cNvCxnSpPr/>
+          <p:nvPr/>
+        </p:nvCxnSpPr>
+        <p:spPr>
+          <a:xfrm>
+            <a:off x="505835" y="19535515"/>
+            <a:ext cx="14105107" cy="0"/>
+          </a:xfrm>
+          <a:prstGeom prst="line">
+            <a:avLst/>
+          </a:prstGeom>
+          <a:ln w="76200"/>
+        </p:spPr>
+        <p:style>
+          <a:lnRef idx="2">
+            <a:schemeClr val="dk1"/>
+          </a:lnRef>
+          <a:fillRef idx="0">
+            <a:schemeClr val="dk1"/>
+          </a:fillRef>
+          <a:effectRef idx="1">
+            <a:schemeClr val="dk1"/>
+          </a:effectRef>
+          <a:fontRef idx="minor">
+            <a:schemeClr val="tx1"/>
+          </a:fontRef>
+        </p:style>
+      </p:cxnSp>
+      <p:sp>
+        <p:nvSpPr>
+          <p:cNvPr id="7" name="TextBox 6">
+            <a:extLst>
+              <a:ext uri="{FF2B5EF4-FFF2-40B4-BE49-F238E27FC236}">
+                <a16:creationId xmlns:a16="http://schemas.microsoft.com/office/drawing/2014/main" id="{A2959EDA-D5FA-6039-8105-C10A65111E40}"/>
+              </a:ext>
+            </a:extLst>
+          </p:cNvPr>
+          <p:cNvSpPr txBox="1"/>
+          <p:nvPr/>
+        </p:nvSpPr>
+        <p:spPr>
+          <a:xfrm>
+            <a:off x="505835" y="2159539"/>
+            <a:ext cx="6792478" cy="5508431"/>
+          </a:xfrm>
+          <a:prstGeom prst="rect">
+            <a:avLst/>
+          </a:prstGeom>
+          <a:noFill/>
+          <a:ln w="38100">
+            <a:solidFill>
+              <a:schemeClr val="tx1"/>
+            </a:solidFill>
+          </a:ln>
+        </p:spPr>
+        <p:txBody>
+          <a:bodyPr wrap="square" rtlCol="0">
+            <a:spAutoFit/>
+          </a:bodyPr>
+          <a:lstStyle/>
+          <a:p>
+            <a:r>
               <a:rPr lang="en-GB" dirty="0"/>
-            </a:br>
+              <a:t>Problem</a:t>
+            </a:r>
+          </a:p>
+          <a:p>
+            <a:endParaRPr lang="en-GB" dirty="0"/>
+          </a:p>
+          <a:p>
+            <a:endParaRPr lang="en-GB" dirty="0"/>
+          </a:p>
+          <a:p>
+            <a:endParaRPr lang="en-GB" dirty="0"/>
+          </a:p>
+          <a:p>
+            <a:endParaRPr lang="en-GB" dirty="0"/>
+          </a:p>
+          <a:p>
             <a:r>
               <a:rPr lang="en-GB" dirty="0"/>
-              <a:t>30077548@students.southwales.ac.uk</a:t>
-            </a:r>
+              <a:t>Aims</a:t>
+            </a:r>
+          </a:p>
+          <a:p>
+            <a:endParaRPr lang="en-GB" dirty="0"/>
+          </a:p>
+          <a:p>
+            <a:endParaRPr lang="en-GB" dirty="0"/>
+          </a:p>
+          <a:p>
+            <a:endParaRPr lang="en-GB" dirty="0"/>
+          </a:p>
+          <a:p>
+            <a:endParaRPr lang="en-GB" dirty="0"/>
+          </a:p>
+          <a:p>
+            <a:endParaRPr lang="en-GB" dirty="0"/>
+          </a:p>
+          <a:p>
+            <a:endParaRPr lang="en-GB" dirty="0"/>
+          </a:p>
+        </p:txBody>
+      </p:sp>
+      <p:sp>
+        <p:nvSpPr>
+          <p:cNvPr id="8" name="TextBox 7">
+            <a:extLst>
+              <a:ext uri="{FF2B5EF4-FFF2-40B4-BE49-F238E27FC236}">
+                <a16:creationId xmlns:a16="http://schemas.microsoft.com/office/drawing/2014/main" id="{3DA898E7-1F51-F05E-1946-AF27DBBA9962}"/>
+              </a:ext>
+            </a:extLst>
+          </p:cNvPr>
+          <p:cNvSpPr txBox="1"/>
+          <p:nvPr/>
+        </p:nvSpPr>
+        <p:spPr>
+          <a:xfrm>
+            <a:off x="7821038" y="2159539"/>
+            <a:ext cx="6747751" cy="5508431"/>
+          </a:xfrm>
+          <a:prstGeom prst="rect">
+            <a:avLst/>
+          </a:prstGeom>
+          <a:noFill/>
+          <a:ln w="38100">
+            <a:solidFill>
+              <a:schemeClr val="tx1"/>
+            </a:solidFill>
+          </a:ln>
+        </p:spPr>
+        <p:txBody>
+          <a:bodyPr wrap="square" rtlCol="0">
+            <a:spAutoFit/>
+          </a:bodyPr>
+          <a:lstStyle/>
+          <a:p>
+            <a:r>
+              <a:rPr lang="en-GB"/>
+              <a:t>Results</a:t>
+            </a:r>
+            <a:endParaRPr lang="en-GB" dirty="0"/>
+          </a:p>
+          <a:p>
+            <a:endParaRPr lang="en-GB" dirty="0"/>
+          </a:p>
+          <a:p>
+            <a:endParaRPr lang="en-GB" dirty="0"/>
+          </a:p>
+          <a:p>
+            <a:endParaRPr lang="en-GB" dirty="0"/>
+          </a:p>
+          <a:p>
+            <a:endParaRPr lang="en-GB" dirty="0"/>
+          </a:p>
+          <a:p>
+            <a:endParaRPr lang="en-GB" dirty="0"/>
+          </a:p>
+          <a:p>
+            <a:endParaRPr lang="en-GB" dirty="0"/>
+          </a:p>
+          <a:p>
+            <a:endParaRPr lang="en-GB" dirty="0"/>
+          </a:p>
+          <a:p>
+            <a:endParaRPr lang="en-GB" dirty="0"/>
+          </a:p>
+          <a:p>
+            <a:endParaRPr lang="en-GB" dirty="0"/>
+          </a:p>
+          <a:p>
+            <a:endParaRPr lang="en-GB" dirty="0"/>
+          </a:p>
+          <a:p>
+            <a:endParaRPr lang="en-GB" dirty="0"/>
+          </a:p>
+        </p:txBody>
+      </p:sp>
+      <p:sp>
+        <p:nvSpPr>
+          <p:cNvPr id="10" name="TextBox 9">
+            <a:extLst>
+              <a:ext uri="{FF2B5EF4-FFF2-40B4-BE49-F238E27FC236}">
+                <a16:creationId xmlns:a16="http://schemas.microsoft.com/office/drawing/2014/main" id="{14F50158-F9C9-524A-19D2-DF601C3CC995}"/>
+              </a:ext>
+            </a:extLst>
+          </p:cNvPr>
+          <p:cNvSpPr txBox="1"/>
+          <p:nvPr/>
+        </p:nvSpPr>
+        <p:spPr>
+          <a:xfrm>
+            <a:off x="7821037" y="7834852"/>
+            <a:ext cx="6747751" cy="5508431"/>
+          </a:xfrm>
+          <a:prstGeom prst="rect">
+            <a:avLst/>
+          </a:prstGeom>
+          <a:noFill/>
+          <a:ln w="38100">
+            <a:solidFill>
+              <a:schemeClr val="tx1"/>
+            </a:solidFill>
+          </a:ln>
+        </p:spPr>
+        <p:txBody>
+          <a:bodyPr wrap="square" rtlCol="0">
+            <a:spAutoFit/>
+          </a:bodyPr>
+          <a:lstStyle/>
+          <a:p>
+            <a:r>
+              <a:rPr lang="en-GB" dirty="0"/>
+              <a:t>Conclusion</a:t>
+            </a:r>
+          </a:p>
+          <a:p>
+            <a:endParaRPr lang="en-GB" dirty="0"/>
+          </a:p>
+          <a:p>
+            <a:endParaRPr lang="en-GB" dirty="0"/>
+          </a:p>
+          <a:p>
+            <a:endParaRPr lang="en-GB" dirty="0"/>
+          </a:p>
+          <a:p>
+            <a:endParaRPr lang="en-GB" dirty="0"/>
+          </a:p>
+          <a:p>
+            <a:endParaRPr lang="en-GB" dirty="0"/>
+          </a:p>
+          <a:p>
+            <a:endParaRPr lang="en-GB" dirty="0"/>
+          </a:p>
+          <a:p>
+            <a:endParaRPr lang="en-GB" dirty="0"/>
+          </a:p>
+          <a:p>
+            <a:endParaRPr lang="en-GB" dirty="0"/>
+          </a:p>
+          <a:p>
+            <a:endParaRPr lang="en-GB" dirty="0"/>
+          </a:p>
+          <a:p>
+            <a:endParaRPr lang="en-GB" dirty="0"/>
+          </a:p>
+          <a:p>
+            <a:endParaRPr lang="en-GB" dirty="0"/>
+          </a:p>
+        </p:txBody>
+      </p:sp>
+      <p:sp>
+        <p:nvSpPr>
+          <p:cNvPr id="11" name="TextBox 10">
+            <a:extLst>
+              <a:ext uri="{FF2B5EF4-FFF2-40B4-BE49-F238E27FC236}">
+                <a16:creationId xmlns:a16="http://schemas.microsoft.com/office/drawing/2014/main" id="{8C736118-621A-11A8-2DF2-A76561E9AAE6}"/>
+              </a:ext>
+            </a:extLst>
+          </p:cNvPr>
+          <p:cNvSpPr txBox="1"/>
+          <p:nvPr/>
+        </p:nvSpPr>
+        <p:spPr>
+          <a:xfrm>
+            <a:off x="505835" y="13724093"/>
+            <a:ext cx="6792478" cy="5508431"/>
+          </a:xfrm>
+          <a:prstGeom prst="rect">
+            <a:avLst/>
+          </a:prstGeom>
+          <a:noFill/>
+          <a:ln w="38100">
+            <a:solidFill>
+              <a:schemeClr val="tx1"/>
+            </a:solidFill>
+          </a:ln>
+        </p:spPr>
+        <p:txBody>
+          <a:bodyPr wrap="square" rtlCol="0">
+            <a:spAutoFit/>
+          </a:bodyPr>
+          <a:lstStyle/>
+          <a:p>
+            <a:r>
+              <a:rPr lang="en-GB" dirty="0"/>
+              <a:t>Development Process</a:t>
+            </a:r>
+          </a:p>
+          <a:p>
+            <a:endParaRPr lang="en-GB" dirty="0"/>
+          </a:p>
+          <a:p>
+            <a:endParaRPr lang="en-GB" dirty="0"/>
+          </a:p>
+          <a:p>
+            <a:endParaRPr lang="en-GB" dirty="0"/>
+          </a:p>
+          <a:p>
+            <a:endParaRPr lang="en-GB" dirty="0"/>
+          </a:p>
+          <a:p>
+            <a:endParaRPr lang="en-GB" dirty="0"/>
+          </a:p>
+          <a:p>
+            <a:endParaRPr lang="en-GB" dirty="0"/>
+          </a:p>
+          <a:p>
+            <a:endParaRPr lang="en-GB" dirty="0"/>
+          </a:p>
+          <a:p>
+            <a:endParaRPr lang="en-GB" dirty="0"/>
+          </a:p>
+          <a:p>
+            <a:endParaRPr lang="en-GB" dirty="0"/>
+          </a:p>
+          <a:p>
+            <a:endParaRPr lang="en-GB" dirty="0"/>
+          </a:p>
+          <a:p>
+            <a:endParaRPr lang="en-GB" dirty="0"/>
+          </a:p>
+        </p:txBody>
+      </p:sp>
+      <p:sp>
+        <p:nvSpPr>
+          <p:cNvPr id="12" name="TextBox 11">
+            <a:extLst>
+              <a:ext uri="{FF2B5EF4-FFF2-40B4-BE49-F238E27FC236}">
+                <a16:creationId xmlns:a16="http://schemas.microsoft.com/office/drawing/2014/main" id="{8816A9FA-50CD-BDF4-C168-DAED2BFC33A4}"/>
+              </a:ext>
+            </a:extLst>
+          </p:cNvPr>
+          <p:cNvSpPr txBox="1"/>
+          <p:nvPr/>
+        </p:nvSpPr>
+        <p:spPr>
+          <a:xfrm>
+            <a:off x="7821038" y="13724093"/>
+            <a:ext cx="6747751" cy="5508431"/>
+          </a:xfrm>
+          <a:prstGeom prst="rect">
+            <a:avLst/>
+          </a:prstGeom>
+          <a:noFill/>
+          <a:ln w="38100">
+            <a:solidFill>
+              <a:schemeClr val="tx1"/>
+            </a:solidFill>
+          </a:ln>
+        </p:spPr>
+        <p:txBody>
+          <a:bodyPr wrap="square" rtlCol="0">
+            <a:spAutoFit/>
+          </a:bodyPr>
+          <a:lstStyle/>
+          <a:p>
+            <a:r>
+              <a:rPr lang="en-GB" dirty="0"/>
+              <a:t>Future Work</a:t>
+            </a:r>
+          </a:p>
+          <a:p>
+            <a:endParaRPr lang="en-GB" dirty="0"/>
+          </a:p>
+          <a:p>
+            <a:endParaRPr lang="en-GB" dirty="0"/>
+          </a:p>
+          <a:p>
+            <a:endParaRPr lang="en-GB" dirty="0"/>
+          </a:p>
+          <a:p>
+            <a:endParaRPr lang="en-GB" dirty="0"/>
+          </a:p>
+          <a:p>
+            <a:endParaRPr lang="en-GB" dirty="0"/>
+          </a:p>
+          <a:p>
+            <a:endParaRPr lang="en-GB" dirty="0"/>
+          </a:p>
+          <a:p>
+            <a:endParaRPr lang="en-GB" dirty="0"/>
+          </a:p>
+          <a:p>
+            <a:endParaRPr lang="en-GB" dirty="0"/>
+          </a:p>
+          <a:p>
+            <a:endParaRPr lang="en-GB" dirty="0"/>
+          </a:p>
+          <a:p>
+            <a:endParaRPr lang="en-GB" dirty="0"/>
+          </a:p>
+          <a:p>
+            <a:endParaRPr lang="en-GB" dirty="0"/>
           </a:p>
         </p:txBody>
       </p:sp>

</xml_diff>

<commit_message>
Added the QR codes in for the asset sources and licenses and the reference list
</commit_message>
<xml_diff>
--- a/30077548ProjectPoster.pptx
+++ b/30077548ProjectPoster.pptx
@@ -3858,6 +3858,78 @@
           </a:p>
         </p:txBody>
       </p:sp>
+      <p:pic>
+        <p:nvPicPr>
+          <p:cNvPr id="9" name="Picture 8">
+            <a:extLst>
+              <a:ext uri="{FF2B5EF4-FFF2-40B4-BE49-F238E27FC236}">
+                <a16:creationId xmlns:a16="http://schemas.microsoft.com/office/drawing/2014/main" id="{0C23F8B5-6FC1-0BEB-9776-4F00E3718697}"/>
+              </a:ext>
+            </a:extLst>
+          </p:cNvPr>
+          <p:cNvPicPr>
+            <a:picLocks noChangeAspect="1"/>
+          </p:cNvPicPr>
+          <p:nvPr/>
+        </p:nvPicPr>
+        <p:blipFill>
+          <a:blip r:embed="rId2">
+            <a:extLst>
+              <a:ext uri="{28A0092B-C50C-407E-A947-70E740481C1C}">
+                <a14:useLocalDpi xmlns:a14="http://schemas.microsoft.com/office/drawing/2010/main" val="0"/>
+              </a:ext>
+            </a:extLst>
+          </a:blip>
+          <a:stretch>
+            <a:fillRect/>
+          </a:stretch>
+        </p:blipFill>
+        <p:spPr>
+          <a:xfrm>
+            <a:off x="27836" y="19673634"/>
+            <a:ext cx="1295126" cy="1678914"/>
+          </a:xfrm>
+          <a:prstGeom prst="rect">
+            <a:avLst/>
+          </a:prstGeom>
+        </p:spPr>
+      </p:pic>
+      <p:pic>
+        <p:nvPicPr>
+          <p:cNvPr id="14" name="Picture 13">
+            <a:extLst>
+              <a:ext uri="{FF2B5EF4-FFF2-40B4-BE49-F238E27FC236}">
+                <a16:creationId xmlns:a16="http://schemas.microsoft.com/office/drawing/2014/main" id="{E91EC4BA-633C-84D8-470A-0A349FCA4769}"/>
+              </a:ext>
+            </a:extLst>
+          </p:cNvPr>
+          <p:cNvPicPr>
+            <a:picLocks noChangeAspect="1"/>
+          </p:cNvPicPr>
+          <p:nvPr/>
+        </p:nvPicPr>
+        <p:blipFill>
+          <a:blip r:embed="rId3">
+            <a:extLst>
+              <a:ext uri="{28A0092B-C50C-407E-A947-70E740481C1C}">
+                <a14:useLocalDpi xmlns:a14="http://schemas.microsoft.com/office/drawing/2010/main" val="0"/>
+              </a:ext>
+            </a:extLst>
+          </a:blip>
+          <a:stretch>
+            <a:fillRect/>
+          </a:stretch>
+        </p:blipFill>
+        <p:spPr>
+          <a:xfrm>
+            <a:off x="13599268" y="19612329"/>
+            <a:ext cx="1492246" cy="1771296"/>
+          </a:xfrm>
+          <a:prstGeom prst="rect">
+            <a:avLst/>
+          </a:prstGeom>
+        </p:spPr>
+      </p:pic>
     </p:spTree>
     <p:extLst>
       <p:ext uri="{BB962C8B-B14F-4D97-AF65-F5344CB8AC3E}">

</xml_diff>

<commit_message>
Formatted background and layout of the poster
</commit_message>
<xml_diff>
--- a/30077548ProjectPoster.pptx
+++ b/30077548ProjectPoster.pptx
@@ -3333,6 +3333,14 @@
 <file path=ppt/slides/slide1.xml><?xml version="1.0" encoding="utf-8"?>
 <p:sld xmlns:a="http://schemas.openxmlformats.org/drawingml/2006/main" xmlns:r="http://schemas.openxmlformats.org/officeDocument/2006/relationships" xmlns:p="http://schemas.openxmlformats.org/presentationml/2006/main">
   <p:cSld>
+    <p:bg>
+      <p:bgPr>
+        <a:solidFill>
+          <a:schemeClr val="tx1"/>
+        </a:solidFill>
+        <a:effectLst/>
+      </p:bgPr>
+    </p:bg>
     <p:spTree>
       <p:nvGrpSpPr>
         <p:cNvPr id="1" name=""/>
@@ -3347,6 +3355,79 @@
           <a:chExt cx="0" cy="0"/>
         </a:xfrm>
       </p:grpSpPr>
+      <p:pic>
+        <p:nvPicPr>
+          <p:cNvPr id="16" name="Picture 15">
+            <a:extLst>
+              <a:ext uri="{FF2B5EF4-FFF2-40B4-BE49-F238E27FC236}">
+                <a16:creationId xmlns:a16="http://schemas.microsoft.com/office/drawing/2014/main" id="{36F7713A-7D48-6BF1-B533-E5E684632437}"/>
+              </a:ext>
+            </a:extLst>
+          </p:cNvPr>
+          <p:cNvPicPr>
+            <a:picLocks noChangeAspect="1"/>
+          </p:cNvPicPr>
+          <p:nvPr/>
+        </p:nvPicPr>
+        <p:blipFill>
+          <a:blip r:embed="rId2">
+            <a:extLst>
+              <a:ext uri="{28A0092B-C50C-407E-A947-70E740481C1C}">
+                <a14:useLocalDpi xmlns:a14="http://schemas.microsoft.com/office/drawing/2010/main" val="0"/>
+              </a:ext>
+            </a:extLst>
+          </a:blip>
+          <a:srcRect l="-45" r="10580"/>
+          <a:stretch>
+            <a:fillRect/>
+          </a:stretch>
+        </p:blipFill>
+        <p:spPr>
+          <a:xfrm>
+            <a:off x="27836" y="11272518"/>
+            <a:ext cx="15091514" cy="8124879"/>
+          </a:xfrm>
+          <a:prstGeom prst="rect">
+            <a:avLst/>
+          </a:prstGeom>
+        </p:spPr>
+      </p:pic>
+      <p:pic>
+        <p:nvPicPr>
+          <p:cNvPr id="13" name="Picture 12">
+            <a:extLst>
+              <a:ext uri="{FF2B5EF4-FFF2-40B4-BE49-F238E27FC236}">
+                <a16:creationId xmlns:a16="http://schemas.microsoft.com/office/drawing/2014/main" id="{6345E572-F27D-A705-66B6-8BED2357BA2A}"/>
+              </a:ext>
+            </a:extLst>
+          </p:cNvPr>
+          <p:cNvPicPr>
+            <a:picLocks noChangeAspect="1"/>
+          </p:cNvPicPr>
+          <p:nvPr/>
+        </p:nvPicPr>
+        <p:blipFill>
+          <a:blip r:embed="rId3">
+            <a:extLst>
+              <a:ext uri="{28A0092B-C50C-407E-A947-70E740481C1C}">
+                <a14:useLocalDpi xmlns:a14="http://schemas.microsoft.com/office/drawing/2010/main" val="0"/>
+              </a:ext>
+            </a:extLst>
+          </a:blip>
+          <a:stretch>
+            <a:fillRect/>
+          </a:stretch>
+        </p:blipFill>
+        <p:spPr>
+          <a:xfrm>
+            <a:off x="27836" y="2049361"/>
+            <a:ext cx="15063678" cy="9223156"/>
+          </a:xfrm>
+          <a:prstGeom prst="rect">
+            <a:avLst/>
+          </a:prstGeom>
+        </p:spPr>
+      </p:pic>
       <p:sp>
         <p:nvSpPr>
           <p:cNvPr id="2" name="Title 1">
@@ -3368,6 +3449,7 @@
             <a:off x="330740" y="302926"/>
             <a:ext cx="14455303" cy="687930"/>
           </a:xfrm>
+          <a:noFill/>
         </p:spPr>
         <p:txBody>
           <a:bodyPr>
@@ -3376,7 +3458,11 @@
           <a:lstStyle/>
           <a:p>
             <a:r>
-              <a:rPr lang="en-GB" sz="3200" dirty="0"/>
+              <a:rPr lang="en-GB" sz="3200" dirty="0">
+                <a:solidFill>
+                  <a:schemeClr val="bg1"/>
+                </a:solidFill>
+              </a:rPr>
               <a:t>An Educational Virtual Reality Approach to Raising Awareness of Digital Eye Strain</a:t>
             </a:r>
           </a:p>
@@ -3409,7 +3495,11 @@
           <a:lstStyle/>
           <a:p>
             <a:r>
-              <a:rPr lang="en-GB" dirty="0"/>
+              <a:rPr lang="en-GB" dirty="0">
+                <a:solidFill>
+                  <a:schemeClr val="bg1"/>
+                </a:solidFill>
+              </a:rPr>
               <a:t>Supervisor – Alun King	30077548 – Sebastian Ha	30077548@students.southwales.ac.uk</a:t>
             </a:r>
           </a:p>
@@ -3435,7 +3525,11 @@
           <a:prstGeom prst="line">
             <a:avLst/>
           </a:prstGeom>
-          <a:ln w="76200"/>
+          <a:ln w="76200">
+            <a:solidFill>
+              <a:schemeClr val="bg1"/>
+            </a:solidFill>
+          </a:ln>
         </p:spPr>
         <p:style>
           <a:lnRef idx="2">
@@ -3472,7 +3566,11 @@
           <a:prstGeom prst="line">
             <a:avLst/>
           </a:prstGeom>
-          <a:ln w="76200"/>
+          <a:ln w="76200">
+            <a:solidFill>
+              <a:schemeClr val="bg1"/>
+            </a:solidFill>
+          </a:ln>
         </p:spPr>
         <p:style>
           <a:lnRef idx="2">
@@ -3504,7 +3602,7 @@
         <p:spPr>
           <a:xfrm>
             <a:off x="505835" y="2159539"/>
-            <a:ext cx="6792478" cy="5508431"/>
+            <a:ext cx="6850844" cy="5508431"/>
           </a:xfrm>
           <a:prstGeom prst="rect">
             <a:avLst/>
@@ -3512,7 +3610,7 @@
           <a:noFill/>
           <a:ln w="38100">
             <a:solidFill>
-              <a:schemeClr val="tx1"/>
+              <a:schemeClr val="bg1"/>
             </a:solidFill>
           </a:ln>
         </p:spPr>
@@ -3523,45 +3621,93 @@
           <a:lstStyle/>
           <a:p>
             <a:r>
-              <a:rPr lang="en-GB" dirty="0"/>
+              <a:rPr lang="en-GB" dirty="0">
+                <a:solidFill>
+                  <a:schemeClr val="bg1"/>
+                </a:solidFill>
+              </a:rPr>
               <a:t>Problem</a:t>
             </a:r>
           </a:p>
           <a:p>
-            <a:endParaRPr lang="en-GB" dirty="0"/>
-          </a:p>
-          <a:p>
-            <a:endParaRPr lang="en-GB" dirty="0"/>
-          </a:p>
-          <a:p>
-            <a:endParaRPr lang="en-GB" dirty="0"/>
-          </a:p>
-          <a:p>
-            <a:endParaRPr lang="en-GB" dirty="0"/>
-          </a:p>
-          <a:p>
-            <a:r>
-              <a:rPr lang="en-GB" dirty="0"/>
+            <a:endParaRPr lang="en-GB" dirty="0">
+              <a:solidFill>
+                <a:schemeClr val="bg1"/>
+              </a:solidFill>
+            </a:endParaRPr>
+          </a:p>
+          <a:p>
+            <a:endParaRPr lang="en-GB" dirty="0">
+              <a:solidFill>
+                <a:schemeClr val="bg1"/>
+              </a:solidFill>
+            </a:endParaRPr>
+          </a:p>
+          <a:p>
+            <a:endParaRPr lang="en-GB" dirty="0">
+              <a:solidFill>
+                <a:schemeClr val="bg1"/>
+              </a:solidFill>
+            </a:endParaRPr>
+          </a:p>
+          <a:p>
+            <a:endParaRPr lang="en-GB" dirty="0">
+              <a:solidFill>
+                <a:schemeClr val="bg1"/>
+              </a:solidFill>
+            </a:endParaRPr>
+          </a:p>
+          <a:p>
+            <a:r>
+              <a:rPr lang="en-GB" dirty="0">
+                <a:solidFill>
+                  <a:schemeClr val="bg1"/>
+                </a:solidFill>
+              </a:rPr>
               <a:t>Aims</a:t>
             </a:r>
           </a:p>
           <a:p>
-            <a:endParaRPr lang="en-GB" dirty="0"/>
-          </a:p>
-          <a:p>
-            <a:endParaRPr lang="en-GB" dirty="0"/>
-          </a:p>
-          <a:p>
-            <a:endParaRPr lang="en-GB" dirty="0"/>
-          </a:p>
-          <a:p>
-            <a:endParaRPr lang="en-GB" dirty="0"/>
-          </a:p>
-          <a:p>
-            <a:endParaRPr lang="en-GB" dirty="0"/>
-          </a:p>
-          <a:p>
-            <a:endParaRPr lang="en-GB" dirty="0"/>
+            <a:endParaRPr lang="en-GB" dirty="0">
+              <a:solidFill>
+                <a:schemeClr val="bg1"/>
+              </a:solidFill>
+            </a:endParaRPr>
+          </a:p>
+          <a:p>
+            <a:endParaRPr lang="en-GB" dirty="0">
+              <a:solidFill>
+                <a:schemeClr val="bg1"/>
+              </a:solidFill>
+            </a:endParaRPr>
+          </a:p>
+          <a:p>
+            <a:endParaRPr lang="en-GB" dirty="0">
+              <a:solidFill>
+                <a:schemeClr val="bg1"/>
+              </a:solidFill>
+            </a:endParaRPr>
+          </a:p>
+          <a:p>
+            <a:endParaRPr lang="en-GB" dirty="0">
+              <a:solidFill>
+                <a:schemeClr val="bg1"/>
+              </a:solidFill>
+            </a:endParaRPr>
+          </a:p>
+          <a:p>
+            <a:endParaRPr lang="en-GB" dirty="0">
+              <a:solidFill>
+                <a:schemeClr val="bg1"/>
+              </a:solidFill>
+            </a:endParaRPr>
+          </a:p>
+          <a:p>
+            <a:endParaRPr lang="en-GB" dirty="0">
+              <a:solidFill>
+                <a:schemeClr val="bg1"/>
+              </a:solidFill>
+            </a:endParaRPr>
           </a:p>
         </p:txBody>
       </p:sp>
@@ -3579,8 +3725,8 @@
         </p:nvSpPr>
         <p:spPr>
           <a:xfrm>
-            <a:off x="7821038" y="2159539"/>
-            <a:ext cx="6747751" cy="5508431"/>
+            <a:off x="7834678" y="2159539"/>
+            <a:ext cx="6734112" cy="5508431"/>
           </a:xfrm>
           <a:prstGeom prst="rect">
             <a:avLst/>
@@ -3588,7 +3734,7 @@
           <a:noFill/>
           <a:ln w="38100">
             <a:solidFill>
-              <a:schemeClr val="tx1"/>
+              <a:schemeClr val="bg1"/>
             </a:solidFill>
           </a:ln>
         </p:spPr>
@@ -3599,40 +3745,83 @@
           <a:lstStyle/>
           <a:p>
             <a:r>
-              <a:rPr lang="en-GB"/>
+              <a:rPr lang="en-GB" dirty="0">
+                <a:solidFill>
+                  <a:schemeClr val="bg1"/>
+                </a:solidFill>
+              </a:rPr>
               <a:t>Results</a:t>
             </a:r>
-            <a:endParaRPr lang="en-GB" dirty="0"/>
-          </a:p>
-          <a:p>
-            <a:endParaRPr lang="en-GB" dirty="0"/>
-          </a:p>
-          <a:p>
-            <a:endParaRPr lang="en-GB" dirty="0"/>
-          </a:p>
-          <a:p>
-            <a:endParaRPr lang="en-GB" dirty="0"/>
-          </a:p>
-          <a:p>
-            <a:endParaRPr lang="en-GB" dirty="0"/>
-          </a:p>
-          <a:p>
-            <a:endParaRPr lang="en-GB" dirty="0"/>
-          </a:p>
-          <a:p>
-            <a:endParaRPr lang="en-GB" dirty="0"/>
-          </a:p>
-          <a:p>
-            <a:endParaRPr lang="en-GB" dirty="0"/>
-          </a:p>
-          <a:p>
-            <a:endParaRPr lang="en-GB" dirty="0"/>
-          </a:p>
-          <a:p>
-            <a:endParaRPr lang="en-GB" dirty="0"/>
-          </a:p>
-          <a:p>
-            <a:endParaRPr lang="en-GB" dirty="0"/>
+          </a:p>
+          <a:p>
+            <a:endParaRPr lang="en-GB" dirty="0">
+              <a:solidFill>
+                <a:schemeClr val="bg1"/>
+              </a:solidFill>
+            </a:endParaRPr>
+          </a:p>
+          <a:p>
+            <a:endParaRPr lang="en-GB" dirty="0">
+              <a:solidFill>
+                <a:schemeClr val="bg1"/>
+              </a:solidFill>
+            </a:endParaRPr>
+          </a:p>
+          <a:p>
+            <a:endParaRPr lang="en-GB" dirty="0">
+              <a:solidFill>
+                <a:schemeClr val="bg1"/>
+              </a:solidFill>
+            </a:endParaRPr>
+          </a:p>
+          <a:p>
+            <a:endParaRPr lang="en-GB" dirty="0">
+              <a:solidFill>
+                <a:schemeClr val="bg1"/>
+              </a:solidFill>
+            </a:endParaRPr>
+          </a:p>
+          <a:p>
+            <a:endParaRPr lang="en-GB" dirty="0">
+              <a:solidFill>
+                <a:schemeClr val="bg1"/>
+              </a:solidFill>
+            </a:endParaRPr>
+          </a:p>
+          <a:p>
+            <a:endParaRPr lang="en-GB" dirty="0">
+              <a:solidFill>
+                <a:schemeClr val="bg1"/>
+              </a:solidFill>
+            </a:endParaRPr>
+          </a:p>
+          <a:p>
+            <a:endParaRPr lang="en-GB" dirty="0">
+              <a:solidFill>
+                <a:schemeClr val="bg1"/>
+              </a:solidFill>
+            </a:endParaRPr>
+          </a:p>
+          <a:p>
+            <a:endParaRPr lang="en-GB" dirty="0">
+              <a:solidFill>
+                <a:schemeClr val="bg1"/>
+              </a:solidFill>
+            </a:endParaRPr>
+          </a:p>
+          <a:p>
+            <a:endParaRPr lang="en-GB" dirty="0">
+              <a:solidFill>
+                <a:schemeClr val="bg1"/>
+              </a:solidFill>
+            </a:endParaRPr>
+          </a:p>
+          <a:p>
+            <a:endParaRPr lang="en-GB" dirty="0">
+              <a:solidFill>
+                <a:schemeClr val="bg1"/>
+              </a:solidFill>
+            </a:endParaRPr>
           </a:p>
           <a:p>
             <a:endParaRPr lang="en-GB" dirty="0"/>
@@ -3653,8 +3842,8 @@
         </p:nvSpPr>
         <p:spPr>
           <a:xfrm>
-            <a:off x="7821037" y="7834852"/>
-            <a:ext cx="6747751" cy="5508431"/>
+            <a:off x="7834677" y="7937596"/>
+            <a:ext cx="6734112" cy="5508431"/>
           </a:xfrm>
           <a:prstGeom prst="rect">
             <a:avLst/>
@@ -3662,7 +3851,7 @@
           <a:noFill/>
           <a:ln w="38100">
             <a:solidFill>
-              <a:schemeClr val="tx1"/>
+              <a:schemeClr val="bg1"/>
             </a:solidFill>
           </a:ln>
         </p:spPr>
@@ -3673,39 +3862,83 @@
           <a:lstStyle/>
           <a:p>
             <a:r>
-              <a:rPr lang="en-GB" dirty="0"/>
+              <a:rPr lang="en-GB" dirty="0">
+                <a:solidFill>
+                  <a:schemeClr val="bg1"/>
+                </a:solidFill>
+              </a:rPr>
               <a:t>Conclusion</a:t>
             </a:r>
           </a:p>
           <a:p>
-            <a:endParaRPr lang="en-GB" dirty="0"/>
-          </a:p>
-          <a:p>
-            <a:endParaRPr lang="en-GB" dirty="0"/>
-          </a:p>
-          <a:p>
-            <a:endParaRPr lang="en-GB" dirty="0"/>
-          </a:p>
-          <a:p>
-            <a:endParaRPr lang="en-GB" dirty="0"/>
-          </a:p>
-          <a:p>
-            <a:endParaRPr lang="en-GB" dirty="0"/>
-          </a:p>
-          <a:p>
-            <a:endParaRPr lang="en-GB" dirty="0"/>
-          </a:p>
-          <a:p>
-            <a:endParaRPr lang="en-GB" dirty="0"/>
-          </a:p>
-          <a:p>
-            <a:endParaRPr lang="en-GB" dirty="0"/>
-          </a:p>
-          <a:p>
-            <a:endParaRPr lang="en-GB" dirty="0"/>
-          </a:p>
-          <a:p>
-            <a:endParaRPr lang="en-GB" dirty="0"/>
+            <a:endParaRPr lang="en-GB" dirty="0">
+              <a:solidFill>
+                <a:schemeClr val="bg1"/>
+              </a:solidFill>
+            </a:endParaRPr>
+          </a:p>
+          <a:p>
+            <a:endParaRPr lang="en-GB" dirty="0">
+              <a:solidFill>
+                <a:schemeClr val="bg1"/>
+              </a:solidFill>
+            </a:endParaRPr>
+          </a:p>
+          <a:p>
+            <a:endParaRPr lang="en-GB" dirty="0">
+              <a:solidFill>
+                <a:schemeClr val="bg1"/>
+              </a:solidFill>
+            </a:endParaRPr>
+          </a:p>
+          <a:p>
+            <a:endParaRPr lang="en-GB" dirty="0">
+              <a:solidFill>
+                <a:schemeClr val="bg1"/>
+              </a:solidFill>
+            </a:endParaRPr>
+          </a:p>
+          <a:p>
+            <a:endParaRPr lang="en-GB" dirty="0">
+              <a:solidFill>
+                <a:schemeClr val="bg1"/>
+              </a:solidFill>
+            </a:endParaRPr>
+          </a:p>
+          <a:p>
+            <a:endParaRPr lang="en-GB" dirty="0">
+              <a:solidFill>
+                <a:schemeClr val="bg1"/>
+              </a:solidFill>
+            </a:endParaRPr>
+          </a:p>
+          <a:p>
+            <a:endParaRPr lang="en-GB" dirty="0">
+              <a:solidFill>
+                <a:schemeClr val="bg1"/>
+              </a:solidFill>
+            </a:endParaRPr>
+          </a:p>
+          <a:p>
+            <a:endParaRPr lang="en-GB" dirty="0">
+              <a:solidFill>
+                <a:schemeClr val="bg1"/>
+              </a:solidFill>
+            </a:endParaRPr>
+          </a:p>
+          <a:p>
+            <a:endParaRPr lang="en-GB" dirty="0">
+              <a:solidFill>
+                <a:schemeClr val="bg1"/>
+              </a:solidFill>
+            </a:endParaRPr>
+          </a:p>
+          <a:p>
+            <a:endParaRPr lang="en-GB" dirty="0">
+              <a:solidFill>
+                <a:schemeClr val="bg1"/>
+              </a:solidFill>
+            </a:endParaRPr>
           </a:p>
           <a:p>
             <a:endParaRPr lang="en-GB" dirty="0"/>
@@ -3726,8 +3959,8 @@
         </p:nvSpPr>
         <p:spPr>
           <a:xfrm>
-            <a:off x="505835" y="13724093"/>
-            <a:ext cx="6792478" cy="5508431"/>
+            <a:off x="505834" y="13724093"/>
+            <a:ext cx="6850845" cy="5508431"/>
           </a:xfrm>
           <a:prstGeom prst="rect">
             <a:avLst/>
@@ -3735,7 +3968,7 @@
           <a:noFill/>
           <a:ln w="38100">
             <a:solidFill>
-              <a:schemeClr val="tx1"/>
+              <a:schemeClr val="bg1"/>
             </a:solidFill>
           </a:ln>
         </p:spPr>
@@ -3746,36 +3979,76 @@
           <a:lstStyle/>
           <a:p>
             <a:r>
-              <a:rPr lang="en-GB" dirty="0"/>
+              <a:rPr lang="en-GB" dirty="0">
+                <a:solidFill>
+                  <a:schemeClr val="bg1"/>
+                </a:solidFill>
+              </a:rPr>
               <a:t>Development Process</a:t>
             </a:r>
           </a:p>
           <a:p>
-            <a:endParaRPr lang="en-GB" dirty="0"/>
-          </a:p>
-          <a:p>
-            <a:endParaRPr lang="en-GB" dirty="0"/>
-          </a:p>
-          <a:p>
-            <a:endParaRPr lang="en-GB" dirty="0"/>
-          </a:p>
-          <a:p>
-            <a:endParaRPr lang="en-GB" dirty="0"/>
-          </a:p>
-          <a:p>
-            <a:endParaRPr lang="en-GB" dirty="0"/>
-          </a:p>
-          <a:p>
-            <a:endParaRPr lang="en-GB" dirty="0"/>
-          </a:p>
-          <a:p>
-            <a:endParaRPr lang="en-GB" dirty="0"/>
-          </a:p>
-          <a:p>
-            <a:endParaRPr lang="en-GB" dirty="0"/>
-          </a:p>
-          <a:p>
-            <a:endParaRPr lang="en-GB" dirty="0"/>
+            <a:endParaRPr lang="en-GB" dirty="0">
+              <a:solidFill>
+                <a:schemeClr val="bg1"/>
+              </a:solidFill>
+            </a:endParaRPr>
+          </a:p>
+          <a:p>
+            <a:endParaRPr lang="en-GB" dirty="0">
+              <a:solidFill>
+                <a:schemeClr val="bg1"/>
+              </a:solidFill>
+            </a:endParaRPr>
+          </a:p>
+          <a:p>
+            <a:endParaRPr lang="en-GB" dirty="0">
+              <a:solidFill>
+                <a:schemeClr val="bg1"/>
+              </a:solidFill>
+            </a:endParaRPr>
+          </a:p>
+          <a:p>
+            <a:endParaRPr lang="en-GB" dirty="0">
+              <a:solidFill>
+                <a:schemeClr val="bg1"/>
+              </a:solidFill>
+            </a:endParaRPr>
+          </a:p>
+          <a:p>
+            <a:endParaRPr lang="en-GB" dirty="0">
+              <a:solidFill>
+                <a:schemeClr val="bg1"/>
+              </a:solidFill>
+            </a:endParaRPr>
+          </a:p>
+          <a:p>
+            <a:endParaRPr lang="en-GB" dirty="0">
+              <a:solidFill>
+                <a:schemeClr val="bg1"/>
+              </a:solidFill>
+            </a:endParaRPr>
+          </a:p>
+          <a:p>
+            <a:endParaRPr lang="en-GB" dirty="0">
+              <a:solidFill>
+                <a:schemeClr val="bg1"/>
+              </a:solidFill>
+            </a:endParaRPr>
+          </a:p>
+          <a:p>
+            <a:endParaRPr lang="en-GB" dirty="0">
+              <a:solidFill>
+                <a:schemeClr val="bg1"/>
+              </a:solidFill>
+            </a:endParaRPr>
+          </a:p>
+          <a:p>
+            <a:endParaRPr lang="en-GB" dirty="0">
+              <a:solidFill>
+                <a:schemeClr val="bg1"/>
+              </a:solidFill>
+            </a:endParaRPr>
           </a:p>
           <a:p>
             <a:endParaRPr lang="en-GB" dirty="0"/>
@@ -3799,8 +4072,8 @@
         </p:nvSpPr>
         <p:spPr>
           <a:xfrm>
-            <a:off x="7821038" y="13724093"/>
-            <a:ext cx="6747751" cy="5508431"/>
+            <a:off x="7834676" y="13724093"/>
+            <a:ext cx="6734113" cy="5508431"/>
           </a:xfrm>
           <a:prstGeom prst="rect">
             <a:avLst/>
@@ -3808,7 +4081,7 @@
           <a:noFill/>
           <a:ln w="38100">
             <a:solidFill>
-              <a:schemeClr val="tx1"/>
+              <a:schemeClr val="bg1"/>
             </a:solidFill>
           </a:ln>
         </p:spPr>
@@ -3819,39 +4092,83 @@
           <a:lstStyle/>
           <a:p>
             <a:r>
-              <a:rPr lang="en-GB" dirty="0"/>
+              <a:rPr lang="en-GB" dirty="0">
+                <a:solidFill>
+                  <a:schemeClr val="bg1"/>
+                </a:solidFill>
+              </a:rPr>
               <a:t>Future Work</a:t>
             </a:r>
           </a:p>
           <a:p>
-            <a:endParaRPr lang="en-GB" dirty="0"/>
-          </a:p>
-          <a:p>
-            <a:endParaRPr lang="en-GB" dirty="0"/>
-          </a:p>
-          <a:p>
-            <a:endParaRPr lang="en-GB" dirty="0"/>
-          </a:p>
-          <a:p>
-            <a:endParaRPr lang="en-GB" dirty="0"/>
-          </a:p>
-          <a:p>
-            <a:endParaRPr lang="en-GB" dirty="0"/>
-          </a:p>
-          <a:p>
-            <a:endParaRPr lang="en-GB" dirty="0"/>
-          </a:p>
-          <a:p>
-            <a:endParaRPr lang="en-GB" dirty="0"/>
-          </a:p>
-          <a:p>
-            <a:endParaRPr lang="en-GB" dirty="0"/>
-          </a:p>
-          <a:p>
-            <a:endParaRPr lang="en-GB" dirty="0"/>
-          </a:p>
-          <a:p>
-            <a:endParaRPr lang="en-GB" dirty="0"/>
+            <a:endParaRPr lang="en-GB" dirty="0">
+              <a:solidFill>
+                <a:schemeClr val="bg1"/>
+              </a:solidFill>
+            </a:endParaRPr>
+          </a:p>
+          <a:p>
+            <a:endParaRPr lang="en-GB" dirty="0">
+              <a:solidFill>
+                <a:schemeClr val="bg1"/>
+              </a:solidFill>
+            </a:endParaRPr>
+          </a:p>
+          <a:p>
+            <a:endParaRPr lang="en-GB" dirty="0">
+              <a:solidFill>
+                <a:schemeClr val="bg1"/>
+              </a:solidFill>
+            </a:endParaRPr>
+          </a:p>
+          <a:p>
+            <a:endParaRPr lang="en-GB" dirty="0">
+              <a:solidFill>
+                <a:schemeClr val="bg1"/>
+              </a:solidFill>
+            </a:endParaRPr>
+          </a:p>
+          <a:p>
+            <a:endParaRPr lang="en-GB" dirty="0">
+              <a:solidFill>
+                <a:schemeClr val="bg1"/>
+              </a:solidFill>
+            </a:endParaRPr>
+          </a:p>
+          <a:p>
+            <a:endParaRPr lang="en-GB" dirty="0">
+              <a:solidFill>
+                <a:schemeClr val="bg1"/>
+              </a:solidFill>
+            </a:endParaRPr>
+          </a:p>
+          <a:p>
+            <a:endParaRPr lang="en-GB" dirty="0">
+              <a:solidFill>
+                <a:schemeClr val="bg1"/>
+              </a:solidFill>
+            </a:endParaRPr>
+          </a:p>
+          <a:p>
+            <a:endParaRPr lang="en-GB" dirty="0">
+              <a:solidFill>
+                <a:schemeClr val="bg1"/>
+              </a:solidFill>
+            </a:endParaRPr>
+          </a:p>
+          <a:p>
+            <a:endParaRPr lang="en-GB" dirty="0">
+              <a:solidFill>
+                <a:schemeClr val="bg1"/>
+              </a:solidFill>
+            </a:endParaRPr>
+          </a:p>
+          <a:p>
+            <a:endParaRPr lang="en-GB" dirty="0">
+              <a:solidFill>
+                <a:schemeClr val="bg1"/>
+              </a:solidFill>
+            </a:endParaRPr>
           </a:p>
           <a:p>
             <a:endParaRPr lang="en-GB" dirty="0"/>
@@ -3873,7 +4190,7 @@
           <p:nvPr/>
         </p:nvPicPr>
         <p:blipFill>
-          <a:blip r:embed="rId2">
+          <a:blip r:embed="rId4">
             <a:extLst>
               <a:ext uri="{28A0092B-C50C-407E-A947-70E740481C1C}">
                 <a14:useLocalDpi xmlns:a14="http://schemas.microsoft.com/office/drawing/2010/main" val="0"/>
@@ -3909,7 +4226,7 @@
           <p:nvPr/>
         </p:nvPicPr>
         <p:blipFill>
-          <a:blip r:embed="rId3">
+          <a:blip r:embed="rId5">
             <a:extLst>
               <a:ext uri="{28A0092B-C50C-407E-A947-70E740481C1C}">
                 <a14:useLocalDpi xmlns:a14="http://schemas.microsoft.com/office/drawing/2010/main" val="0"/>

</xml_diff>

<commit_message>
Wrote out start for first section
</commit_message>
<xml_diff>
--- a/30077548ProjectPoster.pptx
+++ b/30077548ProjectPoster.pptx
@@ -3602,7 +3602,7 @@
         <p:spPr>
           <a:xfrm>
             <a:off x="505835" y="2159539"/>
-            <a:ext cx="6850844" cy="5508431"/>
+            <a:ext cx="6850844" cy="4072782"/>
           </a:xfrm>
           <a:prstGeom prst="rect">
             <a:avLst/>
@@ -3630,28 +3630,17 @@
             </a:r>
           </a:p>
           <a:p>
-            <a:endParaRPr lang="en-GB" dirty="0">
-              <a:solidFill>
-                <a:schemeClr val="bg1"/>
-              </a:solidFill>
-            </a:endParaRPr>
-          </a:p>
-          <a:p>
-            <a:endParaRPr lang="en-GB" dirty="0">
-              <a:solidFill>
-                <a:schemeClr val="bg1"/>
-              </a:solidFill>
-            </a:endParaRPr>
-          </a:p>
-          <a:p>
-            <a:endParaRPr lang="en-GB" dirty="0">
-              <a:solidFill>
-                <a:schemeClr val="bg1"/>
-              </a:solidFill>
-            </a:endParaRPr>
-          </a:p>
-          <a:p>
-            <a:endParaRPr lang="en-GB" dirty="0">
+            <a:r>
+              <a:rPr lang="en-GB" sz="2000" dirty="0">
+                <a:solidFill>
+                  <a:schemeClr val="bg1"/>
+                </a:solidFill>
+              </a:rPr>
+              <a:t>Eye strain is caused by prolonged screen use. Symptoms include eye fatigue, light sensitivity, focus strain and headaches. However, awareness of preventative habits remain low.</a:t>
+            </a:r>
+          </a:p>
+          <a:p>
+            <a:endParaRPr lang="en-GB" sz="2000" dirty="0">
               <a:solidFill>
                 <a:schemeClr val="bg1"/>
               </a:solidFill>
@@ -3668,46 +3657,32 @@
             </a:r>
           </a:p>
           <a:p>
-            <a:endParaRPr lang="en-GB" dirty="0">
-              <a:solidFill>
-                <a:schemeClr val="bg1"/>
-              </a:solidFill>
-            </a:endParaRPr>
-          </a:p>
-          <a:p>
-            <a:endParaRPr lang="en-GB" dirty="0">
-              <a:solidFill>
-                <a:schemeClr val="bg1"/>
-              </a:solidFill>
-            </a:endParaRPr>
-          </a:p>
-          <a:p>
-            <a:endParaRPr lang="en-GB" dirty="0">
-              <a:solidFill>
-                <a:schemeClr val="bg1"/>
-              </a:solidFill>
-            </a:endParaRPr>
-          </a:p>
-          <a:p>
-            <a:endParaRPr lang="en-GB" dirty="0">
-              <a:solidFill>
-                <a:schemeClr val="bg1"/>
-              </a:solidFill>
-            </a:endParaRPr>
-          </a:p>
-          <a:p>
-            <a:endParaRPr lang="en-GB" dirty="0">
-              <a:solidFill>
-                <a:schemeClr val="bg1"/>
-              </a:solidFill>
-            </a:endParaRPr>
-          </a:p>
-          <a:p>
-            <a:endParaRPr lang="en-GB" dirty="0">
-              <a:solidFill>
-                <a:schemeClr val="bg1"/>
-              </a:solidFill>
-            </a:endParaRPr>
+            <a:pPr marL="342900" indent="-342900">
+              <a:buFontTx/>
+              <a:buChar char="-"/>
+            </a:pPr>
+            <a:r>
+              <a:rPr lang="en-GB" sz="2000" dirty="0">
+                <a:solidFill>
+                  <a:schemeClr val="bg1"/>
+                </a:solidFill>
+              </a:rPr>
+              <a:t>Develop an immersive VR educational experience that simulates DES symptoms and teaches preventative measures.</a:t>
+            </a:r>
+          </a:p>
+          <a:p>
+            <a:pPr marL="342900" indent="-342900">
+              <a:buFontTx/>
+              <a:buChar char="-"/>
+            </a:pPr>
+            <a:r>
+              <a:rPr lang="en-GB" sz="2000" dirty="0">
+                <a:solidFill>
+                  <a:schemeClr val="bg1"/>
+                </a:solidFill>
+              </a:rPr>
+              <a:t>Use iterative user testing to tailor the experience to the needs of the users.</a:t>
+            </a:r>
           </a:p>
         </p:txBody>
       </p:sp>

</xml_diff>

<commit_message>
Completed first box on poster
</commit_message>
<xml_diff>
--- a/30077548ProjectPoster.pptx
+++ b/30077548ProjectPoster.pptx
@@ -3408,6 +3408,7 @@
         </p:nvPicPr>
         <p:blipFill>
           <a:blip r:embed="rId3">
+            <a:alphaModFix amt="46000"/>
             <a:extLst>
               <a:ext uri="{28A0092B-C50C-407E-A947-70E740481C1C}">
                 <a14:useLocalDpi xmlns:a14="http://schemas.microsoft.com/office/drawing/2010/main" val="0"/>
@@ -3420,12 +3421,15 @@
         </p:blipFill>
         <p:spPr>
           <a:xfrm>
-            <a:off x="27836" y="2049361"/>
+            <a:off x="41754" y="2049361"/>
             <a:ext cx="15063678" cy="9223156"/>
           </a:xfrm>
           <a:prstGeom prst="rect">
             <a:avLst/>
           </a:prstGeom>
+          <a:effectLst>
+            <a:reflection stA="0" endPos="65000" dist="50800" dir="5400000" sy="-100000" algn="bl" rotWithShape="0"/>
+          </a:effectLst>
         </p:spPr>
       </p:pic>
       <p:sp>
@@ -3602,7 +3606,7 @@
         <p:spPr>
           <a:xfrm>
             <a:off x="505835" y="2159539"/>
-            <a:ext cx="6850844" cy="4072782"/>
+            <a:ext cx="6850844" cy="6709337"/>
           </a:xfrm>
           <a:prstGeom prst="rect">
             <a:avLst/>
@@ -3621,7 +3625,7 @@
           <a:lstStyle/>
           <a:p>
             <a:r>
-              <a:rPr lang="en-GB" dirty="0">
+              <a:rPr lang="en-GB" u="sng" dirty="0">
                 <a:solidFill>
                   <a:schemeClr val="bg1"/>
                 </a:solidFill>
@@ -3631,16 +3635,16 @@
           </a:p>
           <a:p>
             <a:r>
-              <a:rPr lang="en-GB" sz="2000" dirty="0">
+              <a:rPr lang="en-GB" sz="1800" dirty="0">
                 <a:solidFill>
                   <a:schemeClr val="bg1"/>
                 </a:solidFill>
               </a:rPr>
-              <a:t>Eye strain is caused by prolonged screen use. Symptoms include eye fatigue, light sensitivity, focus strain and headaches. However, awareness of preventative habits remain low.</a:t>
-            </a:r>
-          </a:p>
-          <a:p>
-            <a:endParaRPr lang="en-GB" sz="2000" dirty="0">
+              <a:t>Digital Eye Strain (DES) is caused by prolonged screen use. Symptoms include eye fatigue, light sensitivity, focus strain and headaches. However, awareness of preventative habits remains low.</a:t>
+            </a:r>
+          </a:p>
+          <a:p>
+            <a:endParaRPr lang="en-GB" sz="1800" dirty="0">
               <a:solidFill>
                 <a:schemeClr val="bg1"/>
               </a:solidFill>
@@ -3648,40 +3652,118 @@
           </a:p>
           <a:p>
             <a:r>
-              <a:rPr lang="en-GB" dirty="0">
+              <a:rPr lang="en-GB" u="sng" dirty="0">
                 <a:solidFill>
                   <a:schemeClr val="bg1"/>
                 </a:solidFill>
               </a:rPr>
-              <a:t>Aims</a:t>
-            </a:r>
-          </a:p>
-          <a:p>
-            <a:pPr marL="342900" indent="-342900">
-              <a:buFontTx/>
-              <a:buChar char="-"/>
-            </a:pPr>
-            <a:r>
-              <a:rPr lang="en-GB" sz="2000" dirty="0">
+              <a:t>Aim</a:t>
+            </a:r>
+          </a:p>
+          <a:p>
+            <a:r>
+              <a:rPr lang="en-GB" sz="1800" dirty="0">
                 <a:solidFill>
                   <a:schemeClr val="bg1"/>
                 </a:solidFill>
               </a:rPr>
-              <a:t>Develop an immersive VR educational experience that simulates DES symptoms and teaches preventative measures.</a:t>
-            </a:r>
-          </a:p>
-          <a:p>
-            <a:pPr marL="342900" indent="-342900">
-              <a:buFontTx/>
-              <a:buChar char="-"/>
-            </a:pPr>
-            <a:r>
-              <a:rPr lang="en-GB" sz="2000" dirty="0">
+              <a:t>Raise awareness of DES by incorporating VR to immerse and engage users with educational material relating to ocular health.</a:t>
+            </a:r>
+          </a:p>
+          <a:p>
+            <a:endParaRPr lang="en-GB" sz="1800" dirty="0">
+              <a:solidFill>
+                <a:schemeClr val="bg1"/>
+              </a:solidFill>
+            </a:endParaRPr>
+          </a:p>
+          <a:p>
+            <a:r>
+              <a:rPr lang="en-GB" u="sng" dirty="0">
                 <a:solidFill>
                   <a:schemeClr val="bg1"/>
                 </a:solidFill>
               </a:rPr>
-              <a:t>Use iterative user testing to tailor the experience to the needs of the users.</a:t>
+              <a:t>Objectives</a:t>
+            </a:r>
+          </a:p>
+          <a:p>
+            <a:pPr marL="342900" lvl="0" indent="-342900">
+              <a:buFont typeface="Wingdings" panose="05000000000000000000" pitchFamily="2" charset="2"/>
+              <a:buChar char="v"/>
+            </a:pPr>
+            <a:r>
+              <a:rPr lang="en-GB" sz="1800" dirty="0">
+                <a:solidFill>
+                  <a:schemeClr val="bg1"/>
+                </a:solidFill>
+              </a:rPr>
+              <a:t>Research preventative methods for DES and identify educational content appropriate for the VR experience. </a:t>
+            </a:r>
+          </a:p>
+          <a:p>
+            <a:pPr lvl="0"/>
+            <a:endParaRPr lang="en-GB" sz="1800" dirty="0">
+              <a:solidFill>
+                <a:schemeClr val="bg1"/>
+              </a:solidFill>
+            </a:endParaRPr>
+          </a:p>
+          <a:p>
+            <a:pPr marL="342900" lvl="0" indent="-342900">
+              <a:buFont typeface="Wingdings" panose="05000000000000000000" pitchFamily="2" charset="2"/>
+              <a:buChar char="v"/>
+            </a:pPr>
+            <a:r>
+              <a:rPr lang="en-GB" sz="1800" dirty="0">
+                <a:solidFill>
+                  <a:schemeClr val="bg1"/>
+                </a:solidFill>
+              </a:rPr>
+              <a:t>Review existing medical VR applications to identify design and interaction strategies.</a:t>
+            </a:r>
+          </a:p>
+          <a:p>
+            <a:pPr lvl="0"/>
+            <a:endParaRPr lang="en-GB" sz="1800" dirty="0">
+              <a:solidFill>
+                <a:schemeClr val="bg1"/>
+              </a:solidFill>
+            </a:endParaRPr>
+          </a:p>
+          <a:p>
+            <a:pPr marL="342900" lvl="0" indent="-342900">
+              <a:buFont typeface="Wingdings" panose="05000000000000000000" pitchFamily="2" charset="2"/>
+              <a:buChar char="v"/>
+            </a:pPr>
+            <a:r>
+              <a:rPr lang="en-GB" sz="1800" dirty="0">
+                <a:solidFill>
+                  <a:schemeClr val="bg1"/>
+                </a:solidFill>
+              </a:rPr>
+              <a:t>Develop a VR experience that simulates DES symptoms and teaches preventative techniques.</a:t>
+            </a:r>
+          </a:p>
+          <a:p>
+            <a:endParaRPr lang="en-GB" sz="1800" dirty="0">
+              <a:solidFill>
+                <a:schemeClr val="bg1"/>
+              </a:solidFill>
+            </a:endParaRPr>
+          </a:p>
+          <a:p>
+            <a:pPr marL="342900" lvl="0" indent="-342900">
+              <a:buFont typeface="Wingdings" panose="05000000000000000000" pitchFamily="2" charset="2"/>
+              <a:buChar char="v"/>
+            </a:pPr>
+            <a:r>
+              <a:rPr lang="en-GB" sz="1800" dirty="0">
+                <a:solidFill>
+                  <a:schemeClr val="bg1"/>
+                </a:solidFill>
+              </a:rPr>
+              <a:t>Conduct user testing to discover issues with the experience to improve upon. </a:t>
             </a:r>
           </a:p>
         </p:txBody>
@@ -3720,7 +3802,7 @@
           <a:lstStyle/>
           <a:p>
             <a:r>
-              <a:rPr lang="en-GB" dirty="0">
+              <a:rPr lang="en-GB" u="sng" dirty="0">
                 <a:solidFill>
                   <a:schemeClr val="bg1"/>
                 </a:solidFill>
@@ -3837,7 +3919,7 @@
           <a:lstStyle/>
           <a:p>
             <a:r>
-              <a:rPr lang="en-GB" dirty="0">
+              <a:rPr lang="en-GB" u="sng" dirty="0">
                 <a:solidFill>
                   <a:schemeClr val="bg1"/>
                 </a:solidFill>
@@ -3954,7 +4036,7 @@
           <a:lstStyle/>
           <a:p>
             <a:r>
-              <a:rPr lang="en-GB" dirty="0">
+              <a:rPr lang="en-GB" u="sng" dirty="0">
                 <a:solidFill>
                   <a:schemeClr val="bg1"/>
                 </a:solidFill>
@@ -4067,7 +4149,7 @@
           <a:lstStyle/>
           <a:p>
             <a:r>
-              <a:rPr lang="en-GB" dirty="0">
+              <a:rPr lang="en-GB" u="sng" dirty="0">
                 <a:solidFill>
                   <a:schemeClr val="bg1"/>
                 </a:solidFill>

</xml_diff>

<commit_message>
Completed results section of poster
</commit_message>
<xml_diff>
--- a/30077548ProjectPoster.pptx
+++ b/30077548ProjectPoster.pptx
@@ -3357,10 +3357,10 @@
       </p:grpSpPr>
       <p:pic>
         <p:nvPicPr>
-          <p:cNvPr id="16" name="Picture 15">
-            <a:extLst>
-              <a:ext uri="{FF2B5EF4-FFF2-40B4-BE49-F238E27FC236}">
-                <a16:creationId xmlns:a16="http://schemas.microsoft.com/office/drawing/2014/main" id="{36F7713A-7D48-6BF1-B533-E5E684632437}"/>
+          <p:cNvPr id="13" name="Picture 12">
+            <a:extLst>
+              <a:ext uri="{FF2B5EF4-FFF2-40B4-BE49-F238E27FC236}">
+                <a16:creationId xmlns:a16="http://schemas.microsoft.com/office/drawing/2014/main" id="{6345E572-F27D-A705-66B6-8BED2357BA2A}"/>
               </a:ext>
             </a:extLst>
           </p:cNvPr>
@@ -3371,6 +3371,48 @@
         </p:nvPicPr>
         <p:blipFill>
           <a:blip r:embed="rId2">
+            <a:alphaModFix amt="46000"/>
+            <a:extLst>
+              <a:ext uri="{28A0092B-C50C-407E-A947-70E740481C1C}">
+                <a14:useLocalDpi xmlns:a14="http://schemas.microsoft.com/office/drawing/2010/main" val="0"/>
+              </a:ext>
+            </a:extLst>
+          </a:blip>
+          <a:srcRect l="-189" r="-112" b="-261"/>
+          <a:stretch>
+            <a:fillRect/>
+          </a:stretch>
+        </p:blipFill>
+        <p:spPr>
+          <a:xfrm>
+            <a:off x="1" y="2020745"/>
+            <a:ext cx="15119350" cy="9253555"/>
+          </a:xfrm>
+          <a:prstGeom prst="rect">
+            <a:avLst/>
+          </a:prstGeom>
+          <a:effectLst>
+            <a:reflection stA="0" endPos="65000" dist="50800" dir="5400000" sy="-100000" algn="bl" rotWithShape="0"/>
+          </a:effectLst>
+        </p:spPr>
+      </p:pic>
+      <p:pic>
+        <p:nvPicPr>
+          <p:cNvPr id="16" name="Picture 15">
+            <a:extLst>
+              <a:ext uri="{FF2B5EF4-FFF2-40B4-BE49-F238E27FC236}">
+                <a16:creationId xmlns:a16="http://schemas.microsoft.com/office/drawing/2014/main" id="{36F7713A-7D48-6BF1-B533-E5E684632437}"/>
+              </a:ext>
+            </a:extLst>
+          </p:cNvPr>
+          <p:cNvPicPr>
+            <a:picLocks noChangeAspect="1"/>
+          </p:cNvPicPr>
+          <p:nvPr/>
+        </p:nvPicPr>
+        <p:blipFill>
+          <a:blip r:embed="rId3">
+            <a:alphaModFix amt="74000"/>
             <a:extLst>
               <a:ext uri="{28A0092B-C50C-407E-A947-70E740481C1C}">
                 <a14:useLocalDpi xmlns:a14="http://schemas.microsoft.com/office/drawing/2010/main" val="0"/>
@@ -3384,52 +3426,12 @@
         </p:blipFill>
         <p:spPr>
           <a:xfrm>
-            <a:off x="27836" y="11272518"/>
+            <a:off x="10461" y="11254847"/>
             <a:ext cx="15091514" cy="8124879"/>
           </a:xfrm>
           <a:prstGeom prst="rect">
             <a:avLst/>
           </a:prstGeom>
-        </p:spPr>
-      </p:pic>
-      <p:pic>
-        <p:nvPicPr>
-          <p:cNvPr id="13" name="Picture 12">
-            <a:extLst>
-              <a:ext uri="{FF2B5EF4-FFF2-40B4-BE49-F238E27FC236}">
-                <a16:creationId xmlns:a16="http://schemas.microsoft.com/office/drawing/2014/main" id="{6345E572-F27D-A705-66B6-8BED2357BA2A}"/>
-              </a:ext>
-            </a:extLst>
-          </p:cNvPr>
-          <p:cNvPicPr>
-            <a:picLocks noChangeAspect="1"/>
-          </p:cNvPicPr>
-          <p:nvPr/>
-        </p:nvPicPr>
-        <p:blipFill>
-          <a:blip r:embed="rId3">
-            <a:alphaModFix amt="46000"/>
-            <a:extLst>
-              <a:ext uri="{28A0092B-C50C-407E-A947-70E740481C1C}">
-                <a14:useLocalDpi xmlns:a14="http://schemas.microsoft.com/office/drawing/2010/main" val="0"/>
-              </a:ext>
-            </a:extLst>
-          </a:blip>
-          <a:stretch>
-            <a:fillRect/>
-          </a:stretch>
-        </p:blipFill>
-        <p:spPr>
-          <a:xfrm>
-            <a:off x="41754" y="2049361"/>
-            <a:ext cx="15063678" cy="9223156"/>
-          </a:xfrm>
-          <a:prstGeom prst="rect">
-            <a:avLst/>
-          </a:prstGeom>
-          <a:effectLst>
-            <a:reflection stA="0" endPos="65000" dist="50800" dir="5400000" sy="-100000" algn="bl" rotWithShape="0"/>
-          </a:effectLst>
         </p:spPr>
       </p:pic>
       <p:sp>
@@ -3605,8 +3607,8 @@
         </p:nvSpPr>
         <p:spPr>
           <a:xfrm>
-            <a:off x="505835" y="2159539"/>
-            <a:ext cx="6850844" cy="6709337"/>
+            <a:off x="505835" y="2151101"/>
+            <a:ext cx="6850844" cy="6986336"/>
           </a:xfrm>
           <a:prstGeom prst="rect">
             <a:avLst/>
@@ -3625,7 +3627,7 @@
           <a:lstStyle/>
           <a:p>
             <a:r>
-              <a:rPr lang="en-GB" u="sng" dirty="0">
+              <a:rPr lang="en-GB" b="1" u="sng" dirty="0">
                 <a:solidFill>
                   <a:schemeClr val="bg1"/>
                 </a:solidFill>
@@ -3640,7 +3642,7 @@
                   <a:schemeClr val="bg1"/>
                 </a:solidFill>
               </a:rPr>
-              <a:t>Digital Eye Strain (DES) is caused by prolonged screen use. Symptoms include eye fatigue, light sensitivity, focus strain and headaches. However, awareness of preventative habits remains low.</a:t>
+              <a:t>Digital Eye Strain (DES) is caused by prolonged screen use with symptoms including eye fatigue, light sensitivity, focus strain and headaches. However, awareness of preventative habits remains low.</a:t>
             </a:r>
           </a:p>
           <a:p>
@@ -3652,7 +3654,7 @@
           </a:p>
           <a:p>
             <a:r>
-              <a:rPr lang="en-GB" u="sng" dirty="0">
+              <a:rPr lang="en-GB" b="1" u="sng" dirty="0">
                 <a:solidFill>
                   <a:schemeClr val="bg1"/>
                 </a:solidFill>
@@ -3667,7 +3669,7 @@
                   <a:schemeClr val="bg1"/>
                 </a:solidFill>
               </a:rPr>
-              <a:t>Raise awareness of DES by incorporating VR to immerse and engage users with educational material relating to ocular health.</a:t>
+              <a:t>Raise awareness of DES by incorporating Virtual Reality (VR) to immerse and engage users with educational material relating to ocular health.</a:t>
             </a:r>
           </a:p>
           <a:p>
@@ -3679,7 +3681,7 @@
           </a:p>
           <a:p>
             <a:r>
-              <a:rPr lang="en-GB" u="sng" dirty="0">
+              <a:rPr lang="en-GB" b="1" u="sng" dirty="0">
                 <a:solidFill>
                   <a:schemeClr val="bg1"/>
                 </a:solidFill>
@@ -3763,7 +3765,7 @@
                   <a:schemeClr val="bg1"/>
                 </a:solidFill>
               </a:rPr>
-              <a:t>Conduct user testing to discover issues with the experience to improve upon. </a:t>
+              <a:t>Conduct user testing to discover issues to improve the experience. </a:t>
             </a:r>
           </a:p>
         </p:txBody>
@@ -3783,7 +3785,7 @@
         <p:spPr>
           <a:xfrm>
             <a:off x="7834678" y="2159539"/>
-            <a:ext cx="6734112" cy="5508431"/>
+            <a:ext cx="6734112" cy="4698659"/>
           </a:xfrm>
           <a:prstGeom prst="rect">
             <a:avLst/>
@@ -3802,7 +3804,7 @@
           <a:lstStyle/>
           <a:p>
             <a:r>
-              <a:rPr lang="en-GB" u="sng" dirty="0">
+              <a:rPr lang="en-GB" b="1" u="sng" dirty="0">
                 <a:solidFill>
                   <a:schemeClr val="bg1"/>
                 </a:solidFill>
@@ -3811,77 +3813,93 @@
             </a:r>
           </a:p>
           <a:p>
-            <a:endParaRPr lang="en-GB" dirty="0">
+            <a:pPr marL="285750" indent="-285750">
+              <a:buFont typeface="Wingdings" panose="05000000000000000000" pitchFamily="2" charset="2"/>
+              <a:buChar char="v"/>
+            </a:pPr>
+            <a:r>
+              <a:rPr lang="en-GB" sz="1800" dirty="0">
+                <a:solidFill>
+                  <a:schemeClr val="bg1"/>
+                </a:solidFill>
+              </a:rPr>
+              <a:t>User testing found usability issues within the prototype with the gaze detection accuracy and the light switch interactions.</a:t>
+            </a:r>
+          </a:p>
+          <a:p>
+            <a:pPr marL="285750" indent="-285750">
+              <a:buFont typeface="Wingdings" panose="05000000000000000000" pitchFamily="2" charset="2"/>
+              <a:buChar char="v"/>
+            </a:pPr>
+            <a:endParaRPr lang="en-GB" sz="1800" dirty="0">
               <a:solidFill>
                 <a:schemeClr val="bg1"/>
               </a:solidFill>
             </a:endParaRPr>
           </a:p>
           <a:p>
-            <a:endParaRPr lang="en-GB" dirty="0">
+            <a:pPr marL="285750" indent="-285750">
+              <a:buFont typeface="Wingdings" panose="05000000000000000000" pitchFamily="2" charset="2"/>
+              <a:buChar char="v"/>
+            </a:pPr>
+            <a:r>
+              <a:rPr lang="en-GB" sz="1800" dirty="0">
+                <a:solidFill>
+                  <a:schemeClr val="bg1"/>
+                </a:solidFill>
+              </a:rPr>
+              <a:t>Iterative improvements reduced interaction complexity while increasing the detection area for the gaze interaction. This resulted in smoother objective progression and reduced frustration.</a:t>
+            </a:r>
+          </a:p>
+          <a:p>
+            <a:pPr marL="285750" indent="-285750">
+              <a:buFont typeface="Wingdings" panose="05000000000000000000" pitchFamily="2" charset="2"/>
+              <a:buChar char="v"/>
+            </a:pPr>
+            <a:endParaRPr lang="en-GB" sz="1800" dirty="0">
               <a:solidFill>
                 <a:schemeClr val="bg1"/>
               </a:solidFill>
             </a:endParaRPr>
           </a:p>
           <a:p>
-            <a:endParaRPr lang="en-GB" dirty="0">
+            <a:pPr marL="285750" indent="-285750">
+              <a:buFont typeface="Wingdings" panose="05000000000000000000" pitchFamily="2" charset="2"/>
+              <a:buChar char="v"/>
+            </a:pPr>
+            <a:r>
+              <a:rPr lang="en-GB" sz="1800" dirty="0">
+                <a:solidFill>
+                  <a:schemeClr val="bg1"/>
+                </a:solidFill>
+              </a:rPr>
+              <a:t>Feedback showed simulated symptoms helped improve user understanding and recognition of the causes, symptoms and preventative measures of DES.</a:t>
+            </a:r>
+          </a:p>
+          <a:p>
+            <a:pPr marL="285750" indent="-285750">
+              <a:buFont typeface="Wingdings" panose="05000000000000000000" pitchFamily="2" charset="2"/>
+              <a:buChar char="v"/>
+            </a:pPr>
+            <a:endParaRPr lang="en-GB" sz="1800" dirty="0">
               <a:solidFill>
                 <a:schemeClr val="bg1"/>
               </a:solidFill>
             </a:endParaRPr>
           </a:p>
           <a:p>
-            <a:endParaRPr lang="en-GB" dirty="0">
-              <a:solidFill>
-                <a:schemeClr val="bg1"/>
-              </a:solidFill>
-            </a:endParaRPr>
-          </a:p>
-          <a:p>
-            <a:endParaRPr lang="en-GB" dirty="0">
-              <a:solidFill>
-                <a:schemeClr val="bg1"/>
-              </a:solidFill>
-            </a:endParaRPr>
-          </a:p>
-          <a:p>
-            <a:endParaRPr lang="en-GB" dirty="0">
-              <a:solidFill>
-                <a:schemeClr val="bg1"/>
-              </a:solidFill>
-            </a:endParaRPr>
-          </a:p>
-          <a:p>
-            <a:endParaRPr lang="en-GB" dirty="0">
-              <a:solidFill>
-                <a:schemeClr val="bg1"/>
-              </a:solidFill>
-            </a:endParaRPr>
-          </a:p>
-          <a:p>
-            <a:endParaRPr lang="en-GB" dirty="0">
-              <a:solidFill>
-                <a:schemeClr val="bg1"/>
-              </a:solidFill>
-            </a:endParaRPr>
-          </a:p>
-          <a:p>
-            <a:endParaRPr lang="en-GB" dirty="0">
-              <a:solidFill>
-                <a:schemeClr val="bg1"/>
-              </a:solidFill>
-            </a:endParaRPr>
-          </a:p>
-          <a:p>
-            <a:endParaRPr lang="en-GB" dirty="0">
-              <a:solidFill>
-                <a:schemeClr val="bg1"/>
-              </a:solidFill>
-            </a:endParaRPr>
-          </a:p>
-          <a:p>
-            <a:endParaRPr lang="en-GB" dirty="0"/>
+            <a:pPr marL="285750" indent="-285750">
+              <a:buFont typeface="Wingdings" panose="05000000000000000000" pitchFamily="2" charset="2"/>
+              <a:buChar char="v"/>
+            </a:pPr>
+            <a:r>
+              <a:rPr lang="en-GB" sz="1800" dirty="0">
+                <a:solidFill>
+                  <a:schemeClr val="bg1"/>
+                </a:solidFill>
+              </a:rPr>
+              <a:t>Final testing confirmed the experience effectively demonstrated symptoms and preventative measures, increasing awareness of DES.</a:t>
+            </a:r>
           </a:p>
         </p:txBody>
       </p:sp>
@@ -3919,7 +3937,7 @@
           <a:lstStyle/>
           <a:p>
             <a:r>
-              <a:rPr lang="en-GB" u="sng" dirty="0">
+              <a:rPr lang="en-GB" b="1" u="sng" dirty="0">
                 <a:solidFill>
                   <a:schemeClr val="bg1"/>
                 </a:solidFill>
@@ -4016,8 +4034,8 @@
         </p:nvSpPr>
         <p:spPr>
           <a:xfrm>
-            <a:off x="505834" y="13724093"/>
-            <a:ext cx="6850845" cy="5508431"/>
+            <a:off x="505833" y="12895659"/>
+            <a:ext cx="6850846" cy="6329874"/>
           </a:xfrm>
           <a:prstGeom prst="rect">
             <a:avLst/>
@@ -4036,7 +4054,7 @@
           <a:lstStyle/>
           <a:p>
             <a:r>
-              <a:rPr lang="en-GB" u="sng" dirty="0">
+              <a:rPr lang="en-GB" b="1" u="sng" dirty="0">
                 <a:solidFill>
                   <a:schemeClr val="bg1"/>
                 </a:solidFill>
@@ -4045,73 +4063,235 @@
             </a:r>
           </a:p>
           <a:p>
-            <a:endParaRPr lang="en-GB" dirty="0">
+            <a:r>
+              <a:rPr lang="en-GB" sz="1800" dirty="0">
+                <a:solidFill>
+                  <a:schemeClr val="bg1"/>
+                </a:solidFill>
+              </a:rPr>
+              <a:t>The project was developed using Unreal Engine 5.3.2 with blueprinting and tested with a Meta Quest 3 VR headset.</a:t>
+            </a:r>
+          </a:p>
+          <a:p>
+            <a:endParaRPr lang="en-GB" sz="1800" dirty="0">
               <a:solidFill>
                 <a:schemeClr val="bg1"/>
               </a:solidFill>
             </a:endParaRPr>
           </a:p>
           <a:p>
-            <a:endParaRPr lang="en-GB" dirty="0">
+            <a:r>
+              <a:rPr lang="en-GB" sz="1800" dirty="0">
+                <a:solidFill>
+                  <a:schemeClr val="bg1"/>
+                </a:solidFill>
+              </a:rPr>
+              <a:t>The development process followed a User Centred Design (UCD) approach, using objective based progression to gamify the experience. The environment was designed to replicate real-world desk environments where DES commonly occurs. </a:t>
+            </a:r>
+          </a:p>
+          <a:p>
+            <a:endParaRPr lang="en-GB" sz="1800" dirty="0">
               <a:solidFill>
                 <a:schemeClr val="bg1"/>
               </a:solidFill>
             </a:endParaRPr>
           </a:p>
           <a:p>
-            <a:endParaRPr lang="en-GB" dirty="0">
+            <a:r>
+              <a:rPr lang="en-GB" sz="1800" dirty="0">
+                <a:solidFill>
+                  <a:schemeClr val="bg1"/>
+                </a:solidFill>
+              </a:rPr>
+              <a:t>Post-processing effects were used to simulate DES symptoms.</a:t>
+            </a:r>
+          </a:p>
+          <a:p>
+            <a:endParaRPr lang="en-GB" sz="1800" dirty="0">
               <a:solidFill>
                 <a:schemeClr val="bg1"/>
               </a:solidFill>
             </a:endParaRPr>
           </a:p>
           <a:p>
-            <a:endParaRPr lang="en-GB" dirty="0">
+            <a:r>
+              <a:rPr lang="en-GB" sz="1800" b="1" dirty="0">
+                <a:solidFill>
+                  <a:schemeClr val="bg1"/>
+                </a:solidFill>
+              </a:rPr>
+              <a:t>Vignette</a:t>
+            </a:r>
+            <a:r>
+              <a:rPr lang="en-GB" sz="1800" dirty="0">
+                <a:solidFill>
+                  <a:schemeClr val="bg1"/>
+                </a:solidFill>
+              </a:rPr>
+              <a:t> </a:t>
+            </a:r>
+            <a:r>
+              <a:rPr lang="en-GB" sz="1800" dirty="0">
+                <a:solidFill>
+                  <a:schemeClr val="bg1"/>
+                </a:solidFill>
+                <a:sym typeface="Wingdings" panose="05000000000000000000" pitchFamily="2" charset="2"/>
+              </a:rPr>
+              <a:t> </a:t>
+            </a:r>
+            <a:r>
+              <a:rPr lang="en-GB" sz="1800" b="1" dirty="0">
+                <a:solidFill>
+                  <a:schemeClr val="bg1"/>
+                </a:solidFill>
+                <a:sym typeface="Wingdings" panose="05000000000000000000" pitchFamily="2" charset="2"/>
+              </a:rPr>
+              <a:t>E</a:t>
+            </a:r>
+            <a:r>
+              <a:rPr lang="en-GB" sz="1800" b="1" dirty="0">
+                <a:solidFill>
+                  <a:schemeClr val="bg1"/>
+                </a:solidFill>
+              </a:rPr>
+              <a:t>ye Fatigue</a:t>
+            </a:r>
+          </a:p>
+          <a:p>
+            <a:r>
+              <a:rPr lang="en-GB" sz="1800" b="1" dirty="0">
+                <a:solidFill>
+                  <a:schemeClr val="bg1"/>
+                </a:solidFill>
+              </a:rPr>
+              <a:t>Bloom</a:t>
+            </a:r>
+            <a:r>
+              <a:rPr lang="en-GB" sz="1800" dirty="0">
+                <a:solidFill>
+                  <a:schemeClr val="bg1"/>
+                </a:solidFill>
+              </a:rPr>
+              <a:t> </a:t>
+            </a:r>
+            <a:r>
+              <a:rPr lang="en-GB" sz="1800" dirty="0">
+                <a:solidFill>
+                  <a:schemeClr val="bg1"/>
+                </a:solidFill>
+                <a:sym typeface="Wingdings" panose="05000000000000000000" pitchFamily="2" charset="2"/>
+              </a:rPr>
+              <a:t> </a:t>
+            </a:r>
+            <a:r>
+              <a:rPr lang="en-GB" sz="1800" b="1" dirty="0">
+                <a:solidFill>
+                  <a:schemeClr val="bg1"/>
+                </a:solidFill>
+                <a:sym typeface="Wingdings" panose="05000000000000000000" pitchFamily="2" charset="2"/>
+              </a:rPr>
+              <a:t>L</a:t>
+            </a:r>
+            <a:r>
+              <a:rPr lang="en-GB" sz="1800" b="1" dirty="0">
+                <a:solidFill>
+                  <a:schemeClr val="bg1"/>
+                </a:solidFill>
+              </a:rPr>
+              <a:t>ight Sensitivity </a:t>
+            </a:r>
+          </a:p>
+          <a:p>
+            <a:r>
+              <a:rPr lang="en-GB" sz="1800" b="1" dirty="0">
+                <a:solidFill>
+                  <a:schemeClr val="bg1"/>
+                </a:solidFill>
+              </a:rPr>
+              <a:t>Blur</a:t>
+            </a:r>
+            <a:r>
+              <a:rPr lang="en-GB" sz="1800" dirty="0">
+                <a:solidFill>
+                  <a:schemeClr val="bg1"/>
+                </a:solidFill>
+              </a:rPr>
+              <a:t> </a:t>
+            </a:r>
+            <a:r>
+              <a:rPr lang="en-GB" sz="1800" dirty="0">
+                <a:solidFill>
+                  <a:schemeClr val="bg1"/>
+                </a:solidFill>
+                <a:sym typeface="Wingdings" panose="05000000000000000000" pitchFamily="2" charset="2"/>
+              </a:rPr>
+              <a:t> </a:t>
+            </a:r>
+            <a:r>
+              <a:rPr lang="en-GB" sz="1800" b="1" dirty="0">
+                <a:solidFill>
+                  <a:schemeClr val="bg1"/>
+                </a:solidFill>
+                <a:sym typeface="Wingdings" panose="05000000000000000000" pitchFamily="2" charset="2"/>
+              </a:rPr>
+              <a:t>F</a:t>
+            </a:r>
+            <a:r>
+              <a:rPr lang="en-GB" sz="1800" b="1" dirty="0">
+                <a:solidFill>
+                  <a:schemeClr val="bg1"/>
+                </a:solidFill>
+              </a:rPr>
+              <a:t>ocus Strain</a:t>
+            </a:r>
+          </a:p>
+          <a:p>
+            <a:endParaRPr lang="en-GB" sz="1800" dirty="0">
               <a:solidFill>
                 <a:schemeClr val="bg1"/>
               </a:solidFill>
             </a:endParaRPr>
           </a:p>
           <a:p>
-            <a:endParaRPr lang="en-GB" dirty="0">
+            <a:r>
+              <a:rPr lang="en-GB" sz="1800" dirty="0">
+                <a:solidFill>
+                  <a:schemeClr val="bg1"/>
+                </a:solidFill>
+              </a:rPr>
+              <a:t>Workflow followed iterative development. A prototype was created and tested by users. Feedback collected was used to improve interactions and usability of the experience. This resulted in the final version implementing improved interaction and gaze detection. </a:t>
+            </a:r>
+          </a:p>
+          <a:p>
+            <a:endParaRPr lang="en-GB" sz="1800" dirty="0">
               <a:solidFill>
                 <a:schemeClr val="bg1"/>
               </a:solidFill>
             </a:endParaRPr>
           </a:p>
           <a:p>
-            <a:endParaRPr lang="en-GB" dirty="0">
+            <a:r>
+              <a:rPr lang="en-GB" sz="1800" b="1" dirty="0">
+                <a:solidFill>
+                  <a:schemeClr val="bg1"/>
+                </a:solidFill>
+              </a:rPr>
+              <a:t>Research </a:t>
+            </a:r>
+            <a:r>
+              <a:rPr lang="en-GB" sz="1800" b="1" dirty="0">
+                <a:solidFill>
+                  <a:schemeClr val="bg1"/>
+                </a:solidFill>
+                <a:sym typeface="Wingdings" panose="05000000000000000000" pitchFamily="2" charset="2"/>
+              </a:rPr>
+              <a:t> Prototype  User Testing  Improvements  Final Version</a:t>
+            </a:r>
+            <a:endParaRPr lang="en-GB" sz="1800" b="1" dirty="0">
               <a:solidFill>
                 <a:schemeClr val="bg1"/>
               </a:solidFill>
             </a:endParaRPr>
-          </a:p>
-          <a:p>
-            <a:endParaRPr lang="en-GB" dirty="0">
-              <a:solidFill>
-                <a:schemeClr val="bg1"/>
-              </a:solidFill>
-            </a:endParaRPr>
-          </a:p>
-          <a:p>
-            <a:endParaRPr lang="en-GB" dirty="0">
-              <a:solidFill>
-                <a:schemeClr val="bg1"/>
-              </a:solidFill>
-            </a:endParaRPr>
-          </a:p>
-          <a:p>
-            <a:endParaRPr lang="en-GB" dirty="0">
-              <a:solidFill>
-                <a:schemeClr val="bg1"/>
-              </a:solidFill>
-            </a:endParaRPr>
-          </a:p>
-          <a:p>
-            <a:endParaRPr lang="en-GB" dirty="0"/>
-          </a:p>
-          <a:p>
-            <a:endParaRPr lang="en-GB" dirty="0"/>
           </a:p>
         </p:txBody>
       </p:sp>
@@ -4149,7 +4329,7 @@
           <a:lstStyle/>
           <a:p>
             <a:r>
-              <a:rPr lang="en-GB" u="sng" dirty="0">
+              <a:rPr lang="en-GB" b="1" u="sng" dirty="0">
                 <a:solidFill>
                   <a:schemeClr val="bg1"/>
                 </a:solidFill>
@@ -4260,7 +4440,7 @@
         </p:blipFill>
         <p:spPr>
           <a:xfrm>
-            <a:off x="27836" y="19673634"/>
+            <a:off x="1872634" y="19658520"/>
             <a:ext cx="1295126" cy="1678914"/>
           </a:xfrm>
           <a:prstGeom prst="rect">
@@ -4296,7 +4476,7 @@
         </p:blipFill>
         <p:spPr>
           <a:xfrm>
-            <a:off x="13599268" y="19612329"/>
+            <a:off x="11850461" y="19612329"/>
             <a:ext cx="1492246" cy="1771296"/>
           </a:xfrm>
           <a:prstGeom prst="rect">
@@ -4304,6 +4484,104 @@
           </a:prstGeom>
         </p:spPr>
       </p:pic>
+      <p:sp>
+        <p:nvSpPr>
+          <p:cNvPr id="4" name="TextBox 3">
+            <a:extLst>
+              <a:ext uri="{FF2B5EF4-FFF2-40B4-BE49-F238E27FC236}">
+                <a16:creationId xmlns:a16="http://schemas.microsoft.com/office/drawing/2014/main" id="{AC329035-6439-40C3-3460-748197047C90}"/>
+              </a:ext>
+            </a:extLst>
+          </p:cNvPr>
+          <p:cNvSpPr txBox="1"/>
+          <p:nvPr/>
+        </p:nvSpPr>
+        <p:spPr>
+          <a:xfrm>
+            <a:off x="3167760" y="20036312"/>
+            <a:ext cx="2217906" cy="461665"/>
+          </a:xfrm>
+          <a:prstGeom prst="rect">
+            <a:avLst/>
+          </a:prstGeom>
+          <a:noFill/>
+        </p:spPr>
+        <p:txBody>
+          <a:bodyPr wrap="square" rtlCol="0">
+            <a:spAutoFit/>
+          </a:bodyPr>
+          <a:lstStyle/>
+          <a:p>
+            <a:r>
+              <a:rPr lang="en-GB" sz="2400" dirty="0">
+                <a:solidFill>
+                  <a:schemeClr val="bg1"/>
+                </a:solidFill>
+                <a:sym typeface="Wingdings" panose="05000000000000000000" pitchFamily="2" charset="2"/>
+              </a:rPr>
+              <a:t></a:t>
+            </a:r>
+            <a:r>
+              <a:rPr lang="en-GB" sz="2400" dirty="0">
+                <a:solidFill>
+                  <a:schemeClr val="bg1"/>
+                </a:solidFill>
+              </a:rPr>
+              <a:t> References</a:t>
+            </a:r>
+            <a:endParaRPr lang="en-GB" dirty="0">
+              <a:solidFill>
+                <a:schemeClr val="bg1"/>
+              </a:solidFill>
+            </a:endParaRPr>
+          </a:p>
+        </p:txBody>
+      </p:sp>
+      <p:sp>
+        <p:nvSpPr>
+          <p:cNvPr id="15" name="TextBox 14">
+            <a:extLst>
+              <a:ext uri="{FF2B5EF4-FFF2-40B4-BE49-F238E27FC236}">
+                <a16:creationId xmlns:a16="http://schemas.microsoft.com/office/drawing/2014/main" id="{B012EC3E-46FF-E236-99D3-9BEE5FE7A7AC}"/>
+              </a:ext>
+            </a:extLst>
+          </p:cNvPr>
+          <p:cNvSpPr txBox="1"/>
+          <p:nvPr/>
+        </p:nvSpPr>
+        <p:spPr>
+          <a:xfrm>
+            <a:off x="8838863" y="20036313"/>
+            <a:ext cx="3011598" cy="461664"/>
+          </a:xfrm>
+          <a:prstGeom prst="rect">
+            <a:avLst/>
+          </a:prstGeom>
+          <a:noFill/>
+        </p:spPr>
+        <p:txBody>
+          <a:bodyPr wrap="square" rtlCol="0">
+            <a:spAutoFit/>
+          </a:bodyPr>
+          <a:lstStyle/>
+          <a:p>
+            <a:r>
+              <a:rPr lang="en-GB" sz="2400" dirty="0">
+                <a:solidFill>
+                  <a:schemeClr val="bg1"/>
+                </a:solidFill>
+                <a:sym typeface="Wingdings" panose="05000000000000000000" pitchFamily="2" charset="2"/>
+              </a:rPr>
+              <a:t>Project Repository </a:t>
+            </a:r>
+            <a:endParaRPr lang="en-GB" dirty="0">
+              <a:solidFill>
+                <a:schemeClr val="bg1"/>
+              </a:solidFill>
+            </a:endParaRPr>
+          </a:p>
+        </p:txBody>
+      </p:sp>
     </p:spTree>
     <p:extLst>
       <p:ext uri="{BB962C8B-B14F-4D97-AF65-F5344CB8AC3E}">

</xml_diff>

<commit_message>
Completed all sections within the poster, time for photos and footer clean up
</commit_message>
<xml_diff>
--- a/30077548ProjectPoster.pptx
+++ b/30077548ProjectPoster.pptx
@@ -3412,7 +3412,7 @@
         </p:nvPicPr>
         <p:blipFill>
           <a:blip r:embed="rId3">
-            <a:alphaModFix amt="74000"/>
+            <a:alphaModFix amt="48000"/>
             <a:extLst>
               <a:ext uri="{28A0092B-C50C-407E-A947-70E740481C1C}">
                 <a14:useLocalDpi xmlns:a14="http://schemas.microsoft.com/office/drawing/2010/main" val="0"/>
@@ -3464,7 +3464,7 @@
           <a:lstStyle/>
           <a:p>
             <a:r>
-              <a:rPr lang="en-GB" sz="3200" dirty="0">
+              <a:rPr lang="en-GB" sz="3200" b="1" dirty="0">
                 <a:solidFill>
                   <a:schemeClr val="bg1"/>
                 </a:solidFill>
@@ -3492,8 +3492,8 @@
         </p:nvSpPr>
         <p:spPr>
           <a:xfrm>
-            <a:off x="2520197" y="1146499"/>
-            <a:ext cx="10076387" cy="687930"/>
+            <a:off x="2360607" y="1129650"/>
+            <a:ext cx="10398135" cy="396546"/>
           </a:xfrm>
         </p:spPr>
         <p:txBody>
@@ -3501,7 +3501,7 @@
           <a:lstStyle/>
           <a:p>
             <a:r>
-              <a:rPr lang="en-GB" dirty="0">
+              <a:rPr lang="en-GB" b="1" dirty="0">
                 <a:solidFill>
                   <a:schemeClr val="bg1"/>
                 </a:solidFill>
@@ -3608,7 +3608,7 @@
         <p:spPr>
           <a:xfrm>
             <a:off x="505835" y="2151101"/>
-            <a:ext cx="6850844" cy="6986336"/>
+            <a:ext cx="6850844" cy="7201780"/>
           </a:xfrm>
           <a:prstGeom prst="rect">
             <a:avLst/>
@@ -3673,7 +3673,7 @@
             </a:r>
           </a:p>
           <a:p>
-            <a:endParaRPr lang="en-GB" sz="1800" dirty="0">
+            <a:endParaRPr lang="en-GB" sz="3200" dirty="0">
               <a:solidFill>
                 <a:schemeClr val="bg1"/>
               </a:solidFill>
@@ -3688,6 +3688,11 @@
               </a:rPr>
               <a:t>Objectives</a:t>
             </a:r>
+            <a:endParaRPr lang="en-GB" sz="1600" b="1" u="sng" dirty="0">
+              <a:solidFill>
+                <a:schemeClr val="bg1"/>
+              </a:solidFill>
+            </a:endParaRPr>
           </a:p>
           <a:p>
             <a:pPr marL="342900" lvl="0" indent="-342900">
@@ -3917,8 +3922,8 @@
         </p:nvSpPr>
         <p:spPr>
           <a:xfrm>
-            <a:off x="7834677" y="7937596"/>
-            <a:ext cx="6734112" cy="5508431"/>
+            <a:off x="7862513" y="7149582"/>
+            <a:ext cx="6734112" cy="2205668"/>
           </a:xfrm>
           <a:prstGeom prst="rect">
             <a:avLst/>
@@ -3946,77 +3951,14 @@
             </a:r>
           </a:p>
           <a:p>
-            <a:endParaRPr lang="en-GB" dirty="0">
-              <a:solidFill>
-                <a:schemeClr val="bg1"/>
-              </a:solidFill>
-            </a:endParaRPr>
-          </a:p>
-          <a:p>
-            <a:endParaRPr lang="en-GB" dirty="0">
-              <a:solidFill>
-                <a:schemeClr val="bg1"/>
-              </a:solidFill>
-            </a:endParaRPr>
-          </a:p>
-          <a:p>
-            <a:endParaRPr lang="en-GB" dirty="0">
-              <a:solidFill>
-                <a:schemeClr val="bg1"/>
-              </a:solidFill>
-            </a:endParaRPr>
-          </a:p>
-          <a:p>
-            <a:endParaRPr lang="en-GB" dirty="0">
-              <a:solidFill>
-                <a:schemeClr val="bg1"/>
-              </a:solidFill>
-            </a:endParaRPr>
-          </a:p>
-          <a:p>
-            <a:endParaRPr lang="en-GB" dirty="0">
-              <a:solidFill>
-                <a:schemeClr val="bg1"/>
-              </a:solidFill>
-            </a:endParaRPr>
-          </a:p>
-          <a:p>
-            <a:endParaRPr lang="en-GB" dirty="0">
-              <a:solidFill>
-                <a:schemeClr val="bg1"/>
-              </a:solidFill>
-            </a:endParaRPr>
-          </a:p>
-          <a:p>
-            <a:endParaRPr lang="en-GB" dirty="0">
-              <a:solidFill>
-                <a:schemeClr val="bg1"/>
-              </a:solidFill>
-            </a:endParaRPr>
-          </a:p>
-          <a:p>
-            <a:endParaRPr lang="en-GB" dirty="0">
-              <a:solidFill>
-                <a:schemeClr val="bg1"/>
-              </a:solidFill>
-            </a:endParaRPr>
-          </a:p>
-          <a:p>
-            <a:endParaRPr lang="en-GB" dirty="0">
-              <a:solidFill>
-                <a:schemeClr val="bg1"/>
-              </a:solidFill>
-            </a:endParaRPr>
-          </a:p>
-          <a:p>
-            <a:endParaRPr lang="en-GB" dirty="0">
-              <a:solidFill>
-                <a:schemeClr val="bg1"/>
-              </a:solidFill>
-            </a:endParaRPr>
-          </a:p>
-          <a:p>
-            <a:endParaRPr lang="en-GB" dirty="0"/>
+            <a:r>
+              <a:rPr lang="en-GB" sz="1800" dirty="0">
+                <a:solidFill>
+                  <a:schemeClr val="bg1"/>
+                </a:solidFill>
+              </a:rPr>
+              <a:t>The experience successfully demonstrated the symptoms and preventative measures of DES. Iterative user testing improved usability and interaction features, which resulted in a more intuitive experience. This shows immersive VR can be used as an effective educational tool for raising awareness of medical health topics.</a:t>
+            </a:r>
           </a:p>
         </p:txBody>
       </p:sp>
@@ -4309,8 +4251,8 @@
         </p:nvSpPr>
         <p:spPr>
           <a:xfrm>
-            <a:off x="7834676" y="13724093"/>
-            <a:ext cx="6734113" cy="5508431"/>
+            <a:off x="7834678" y="12895659"/>
+            <a:ext cx="6761947" cy="3036665"/>
           </a:xfrm>
           <a:prstGeom prst="rect">
             <a:avLst/>
@@ -4336,79 +4278,121 @@
               </a:rPr>
               <a:t>Future Work</a:t>
             </a:r>
-          </a:p>
-          <a:p>
-            <a:endParaRPr lang="en-GB" dirty="0">
+            <a:endParaRPr lang="en-GB" sz="1100" b="1" u="sng" dirty="0">
               <a:solidFill>
                 <a:schemeClr val="bg1"/>
               </a:solidFill>
             </a:endParaRPr>
           </a:p>
           <a:p>
-            <a:endParaRPr lang="en-GB" dirty="0">
+            <a:pPr marL="285750" indent="-285750">
+              <a:buFont typeface="Wingdings" panose="05000000000000000000" pitchFamily="2" charset="2"/>
+              <a:buChar char="v"/>
+            </a:pPr>
+            <a:r>
+              <a:rPr lang="en-GB" sz="1800" dirty="0">
+                <a:solidFill>
+                  <a:schemeClr val="bg1"/>
+                </a:solidFill>
+              </a:rPr>
+              <a:t>Narration within the experience</a:t>
+            </a:r>
+          </a:p>
+          <a:p>
+            <a:pPr marL="285750" indent="-285750">
+              <a:buFont typeface="Wingdings" panose="05000000000000000000" pitchFamily="2" charset="2"/>
+              <a:buChar char="v"/>
+            </a:pPr>
+            <a:endParaRPr lang="en-GB" sz="1800" dirty="0">
               <a:solidFill>
                 <a:schemeClr val="bg1"/>
               </a:solidFill>
             </a:endParaRPr>
           </a:p>
           <a:p>
-            <a:endParaRPr lang="en-GB" dirty="0">
+            <a:pPr marL="285750" indent="-285750">
+              <a:buFont typeface="Wingdings" panose="05000000000000000000" pitchFamily="2" charset="2"/>
+              <a:buChar char="v"/>
+            </a:pPr>
+            <a:r>
+              <a:rPr lang="en-GB" sz="1800" dirty="0">
+                <a:solidFill>
+                  <a:schemeClr val="bg1"/>
+                </a:solidFill>
+              </a:rPr>
+              <a:t>Accessibility settings</a:t>
+            </a:r>
+          </a:p>
+          <a:p>
+            <a:endParaRPr lang="en-GB" sz="1800" dirty="0">
               <a:solidFill>
                 <a:schemeClr val="bg1"/>
               </a:solidFill>
             </a:endParaRPr>
           </a:p>
           <a:p>
-            <a:endParaRPr lang="en-GB" dirty="0">
+            <a:pPr marL="285750" indent="-285750">
+              <a:buFont typeface="Wingdings" panose="05000000000000000000" pitchFamily="2" charset="2"/>
+              <a:buChar char="v"/>
+            </a:pPr>
+            <a:r>
+              <a:rPr lang="en-GB" sz="1800" dirty="0">
+                <a:solidFill>
+                  <a:schemeClr val="bg1"/>
+                </a:solidFill>
+              </a:rPr>
+              <a:t>Changing gaze detection to use eye Tracking</a:t>
+            </a:r>
+          </a:p>
+          <a:p>
+            <a:pPr marL="285750" indent="-285750">
+              <a:buFont typeface="Wingdings" panose="05000000000000000000" pitchFamily="2" charset="2"/>
+              <a:buChar char="v"/>
+            </a:pPr>
+            <a:endParaRPr lang="en-GB" sz="1800" dirty="0">
               <a:solidFill>
                 <a:schemeClr val="bg1"/>
               </a:solidFill>
             </a:endParaRPr>
           </a:p>
           <a:p>
-            <a:endParaRPr lang="en-GB" dirty="0">
+            <a:pPr marL="285750" indent="-285750">
+              <a:buFont typeface="Wingdings" panose="05000000000000000000" pitchFamily="2" charset="2"/>
+              <a:buChar char="v"/>
+            </a:pPr>
+            <a:r>
+              <a:rPr lang="en-GB" sz="1800" dirty="0">
+                <a:solidFill>
+                  <a:schemeClr val="bg1"/>
+                </a:solidFill>
+              </a:rPr>
+              <a:t>Additional environments</a:t>
+            </a:r>
+          </a:p>
+          <a:p>
+            <a:pPr marL="285750" indent="-285750">
+              <a:buFont typeface="Wingdings" panose="05000000000000000000" pitchFamily="2" charset="2"/>
+              <a:buChar char="v"/>
+            </a:pPr>
+            <a:endParaRPr lang="en-GB" sz="1800" dirty="0">
               <a:solidFill>
                 <a:schemeClr val="bg1"/>
               </a:solidFill>
             </a:endParaRPr>
           </a:p>
           <a:p>
-            <a:endParaRPr lang="en-GB" dirty="0">
-              <a:solidFill>
-                <a:schemeClr val="bg1"/>
-              </a:solidFill>
-            </a:endParaRPr>
-          </a:p>
-          <a:p>
-            <a:endParaRPr lang="en-GB" dirty="0">
-              <a:solidFill>
-                <a:schemeClr val="bg1"/>
-              </a:solidFill>
-            </a:endParaRPr>
-          </a:p>
-          <a:p>
-            <a:endParaRPr lang="en-GB" dirty="0">
-              <a:solidFill>
-                <a:schemeClr val="bg1"/>
-              </a:solidFill>
-            </a:endParaRPr>
-          </a:p>
-          <a:p>
-            <a:endParaRPr lang="en-GB" dirty="0">
-              <a:solidFill>
-                <a:schemeClr val="bg1"/>
-              </a:solidFill>
-            </a:endParaRPr>
-          </a:p>
-          <a:p>
-            <a:endParaRPr lang="en-GB" dirty="0">
-              <a:solidFill>
-                <a:schemeClr val="bg1"/>
-              </a:solidFill>
-            </a:endParaRPr>
-          </a:p>
-          <a:p>
-            <a:endParaRPr lang="en-GB" dirty="0"/>
+            <a:pPr marL="285750" indent="-285750">
+              <a:buFont typeface="Wingdings" panose="05000000000000000000" pitchFamily="2" charset="2"/>
+              <a:buChar char="v"/>
+            </a:pPr>
+            <a:r>
+              <a:rPr lang="en-GB" sz="1800" dirty="0">
+                <a:solidFill>
+                  <a:schemeClr val="bg1"/>
+                </a:solidFill>
+              </a:rPr>
+              <a:t>More intuitive light switch interaction </a:t>
+            </a:r>
           </a:p>
         </p:txBody>
       </p:sp>

</xml_diff>

<commit_message>
Removed notes as no longer developing, tidied up the footer a little, carrying on with screenshots etc tomorrow
</commit_message>
<xml_diff>
--- a/30077548ProjectPoster.pptx
+++ b/30077548ProjectPoster.pptx
@@ -4424,7 +4424,7 @@
         </p:blipFill>
         <p:spPr>
           <a:xfrm>
-            <a:off x="1872634" y="19658520"/>
+            <a:off x="146036" y="19683376"/>
             <a:ext cx="1295126" cy="1678914"/>
           </a:xfrm>
           <a:prstGeom prst="rect">
@@ -4460,7 +4460,7 @@
         </p:blipFill>
         <p:spPr>
           <a:xfrm>
-            <a:off x="11850461" y="19612329"/>
+            <a:off x="13640351" y="19612329"/>
             <a:ext cx="1492246" cy="1771296"/>
           </a:xfrm>
           <a:prstGeom prst="rect">
@@ -4482,8 +4482,8 @@
         </p:nvSpPr>
         <p:spPr>
           <a:xfrm>
-            <a:off x="3167760" y="20036312"/>
-            <a:ext cx="2217906" cy="461665"/>
+            <a:off x="1418065" y="20072695"/>
+            <a:ext cx="1480780" cy="400110"/>
           </a:xfrm>
           <a:prstGeom prst="rect">
             <a:avLst/>
@@ -4497,23 +4497,14 @@
           <a:lstStyle/>
           <a:p>
             <a:r>
-              <a:rPr lang="en-GB" sz="2400" dirty="0">
+              <a:rPr lang="en-GB" sz="2000" dirty="0">
                 <a:solidFill>
                   <a:schemeClr val="bg1"/>
                 </a:solidFill>
-                <a:sym typeface="Wingdings" panose="05000000000000000000" pitchFamily="2" charset="2"/>
               </a:rPr>
-              <a:t></a:t>
-            </a:r>
-            <a:r>
-              <a:rPr lang="en-GB" sz="2400" dirty="0">
-                <a:solidFill>
-                  <a:schemeClr val="bg1"/>
-                </a:solidFill>
-              </a:rPr>
-              <a:t> References</a:t>
-            </a:r>
-            <a:endParaRPr lang="en-GB" dirty="0">
+              <a:t>References</a:t>
+            </a:r>
+            <a:endParaRPr lang="en-GB" sz="2400" dirty="0">
               <a:solidFill>
                 <a:schemeClr val="bg1"/>
               </a:solidFill>
@@ -4535,8 +4526,8 @@
         </p:nvSpPr>
         <p:spPr>
           <a:xfrm>
-            <a:off x="8838863" y="20036313"/>
-            <a:ext cx="3011598" cy="461664"/>
+            <a:off x="11589050" y="20036312"/>
+            <a:ext cx="2224226" cy="400110"/>
           </a:xfrm>
           <a:prstGeom prst="rect">
             <a:avLst/>
@@ -4550,15 +4541,15 @@
           <a:lstStyle/>
           <a:p>
             <a:r>
-              <a:rPr lang="en-GB" sz="2400" dirty="0">
+              <a:rPr lang="en-GB" sz="2000" dirty="0">
                 <a:solidFill>
                   <a:schemeClr val="bg1"/>
                 </a:solidFill>
                 <a:sym typeface="Wingdings" panose="05000000000000000000" pitchFamily="2" charset="2"/>
               </a:rPr>
-              <a:t>Project Repository </a:t>
-            </a:r>
-            <a:endParaRPr lang="en-GB" dirty="0">
+              <a:t>Project Repository</a:t>
+            </a:r>
+            <a:endParaRPr lang="en-GB" sz="2800" dirty="0">
               <a:solidFill>
                 <a:schemeClr val="bg1"/>
               </a:solidFill>

</xml_diff>

<commit_message>
Added a photo in
</commit_message>
<xml_diff>
--- a/30077548ProjectPoster.pptx
+++ b/30077548ProjectPoster.pptx
@@ -261,7 +261,7 @@
           <a:p>
             <a:fld id="{2F203B3E-B53B-46D0-941F-66BD0CE762F2}" type="datetimeFigureOut">
               <a:rPr lang="en-GB" smtClean="0"/>
-              <a:t>13/03/2026</a:t>
+              <a:t>14/03/2026</a:t>
             </a:fld>
             <a:endParaRPr lang="en-GB"/>
           </a:p>
@@ -461,7 +461,7 @@
           <a:p>
             <a:fld id="{2F203B3E-B53B-46D0-941F-66BD0CE762F2}" type="datetimeFigureOut">
               <a:rPr lang="en-GB" smtClean="0"/>
-              <a:t>13/03/2026</a:t>
+              <a:t>14/03/2026</a:t>
             </a:fld>
             <a:endParaRPr lang="en-GB"/>
           </a:p>
@@ -671,7 +671,7 @@
           <a:p>
             <a:fld id="{2F203B3E-B53B-46D0-941F-66BD0CE762F2}" type="datetimeFigureOut">
               <a:rPr lang="en-GB" smtClean="0"/>
-              <a:t>13/03/2026</a:t>
+              <a:t>14/03/2026</a:t>
             </a:fld>
             <a:endParaRPr lang="en-GB"/>
           </a:p>
@@ -871,7 +871,7 @@
           <a:p>
             <a:fld id="{2F203B3E-B53B-46D0-941F-66BD0CE762F2}" type="datetimeFigureOut">
               <a:rPr lang="en-GB" smtClean="0"/>
-              <a:t>13/03/2026</a:t>
+              <a:t>14/03/2026</a:t>
             </a:fld>
             <a:endParaRPr lang="en-GB"/>
           </a:p>
@@ -1147,7 +1147,7 @@
           <a:p>
             <a:fld id="{2F203B3E-B53B-46D0-941F-66BD0CE762F2}" type="datetimeFigureOut">
               <a:rPr lang="en-GB" smtClean="0"/>
-              <a:t>13/03/2026</a:t>
+              <a:t>14/03/2026</a:t>
             </a:fld>
             <a:endParaRPr lang="en-GB"/>
           </a:p>
@@ -1415,7 +1415,7 @@
           <a:p>
             <a:fld id="{2F203B3E-B53B-46D0-941F-66BD0CE762F2}" type="datetimeFigureOut">
               <a:rPr lang="en-GB" smtClean="0"/>
-              <a:t>13/03/2026</a:t>
+              <a:t>14/03/2026</a:t>
             </a:fld>
             <a:endParaRPr lang="en-GB"/>
           </a:p>
@@ -1830,7 +1830,7 @@
           <a:p>
             <a:fld id="{2F203B3E-B53B-46D0-941F-66BD0CE762F2}" type="datetimeFigureOut">
               <a:rPr lang="en-GB" smtClean="0"/>
-              <a:t>13/03/2026</a:t>
+              <a:t>14/03/2026</a:t>
             </a:fld>
             <a:endParaRPr lang="en-GB"/>
           </a:p>
@@ -1972,7 +1972,7 @@
           <a:p>
             <a:fld id="{2F203B3E-B53B-46D0-941F-66BD0CE762F2}" type="datetimeFigureOut">
               <a:rPr lang="en-GB" smtClean="0"/>
-              <a:t>13/03/2026</a:t>
+              <a:t>14/03/2026</a:t>
             </a:fld>
             <a:endParaRPr lang="en-GB"/>
           </a:p>
@@ -2085,7 +2085,7 @@
           <a:p>
             <a:fld id="{2F203B3E-B53B-46D0-941F-66BD0CE762F2}" type="datetimeFigureOut">
               <a:rPr lang="en-GB" smtClean="0"/>
-              <a:t>13/03/2026</a:t>
+              <a:t>14/03/2026</a:t>
             </a:fld>
             <a:endParaRPr lang="en-GB"/>
           </a:p>
@@ -2398,7 +2398,7 @@
           <a:p>
             <a:fld id="{2F203B3E-B53B-46D0-941F-66BD0CE762F2}" type="datetimeFigureOut">
               <a:rPr lang="en-GB" smtClean="0"/>
-              <a:t>13/03/2026</a:t>
+              <a:t>14/03/2026</a:t>
             </a:fld>
             <a:endParaRPr lang="en-GB"/>
           </a:p>
@@ -2687,7 +2687,7 @@
           <a:p>
             <a:fld id="{2F203B3E-B53B-46D0-941F-66BD0CE762F2}" type="datetimeFigureOut">
               <a:rPr lang="en-GB" smtClean="0"/>
-              <a:t>13/03/2026</a:t>
+              <a:t>14/03/2026</a:t>
             </a:fld>
             <a:endParaRPr lang="en-GB"/>
           </a:p>
@@ -2930,7 +2930,7 @@
           <a:p>
             <a:fld id="{2F203B3E-B53B-46D0-941F-66BD0CE762F2}" type="datetimeFigureOut">
               <a:rPr lang="en-GB" smtClean="0"/>
-              <a:t>13/03/2026</a:t>
+              <a:t>14/03/2026</a:t>
             </a:fld>
             <a:endParaRPr lang="en-GB"/>
           </a:p>
@@ -3673,7 +3673,7 @@
             </a:r>
           </a:p>
           <a:p>
-            <a:endParaRPr lang="en-GB" sz="3200" dirty="0">
+            <a:endParaRPr lang="en-GB" sz="2000" dirty="0">
               <a:solidFill>
                 <a:schemeClr val="bg1"/>
               </a:solidFill>
@@ -4557,6 +4557,43 @@
           </a:p>
         </p:txBody>
       </p:sp>
+      <p:pic>
+        <p:nvPicPr>
+          <p:cNvPr id="18" name="Picture 17">
+            <a:extLst>
+              <a:ext uri="{FF2B5EF4-FFF2-40B4-BE49-F238E27FC236}">
+                <a16:creationId xmlns:a16="http://schemas.microsoft.com/office/drawing/2014/main" id="{82278756-6B40-1ECB-3CF1-E0C4B49748B5}"/>
+              </a:ext>
+            </a:extLst>
+          </p:cNvPr>
+          <p:cNvPicPr>
+            <a:picLocks noChangeAspect="1"/>
+          </p:cNvPicPr>
+          <p:nvPr/>
+        </p:nvPicPr>
+        <p:blipFill>
+          <a:blip r:embed="rId6">
+            <a:extLst>
+              <a:ext uri="{28A0092B-C50C-407E-A947-70E740481C1C}">
+                <a14:useLocalDpi xmlns:a14="http://schemas.microsoft.com/office/drawing/2010/main" val="0"/>
+              </a:ext>
+            </a:extLst>
+          </a:blip>
+          <a:srcRect l="1051" t="10655" b="4861"/>
+          <a:stretch>
+            <a:fillRect/>
+          </a:stretch>
+        </p:blipFill>
+        <p:spPr>
+          <a:xfrm>
+            <a:off x="7840742" y="16194073"/>
+            <a:ext cx="6734112" cy="3036665"/>
+          </a:xfrm>
+          <a:prstGeom prst="rect">
+            <a:avLst/>
+          </a:prstGeom>
+        </p:spPr>
+      </p:pic>
     </p:spTree>
     <p:extLst>
       <p:ext uri="{BB962C8B-B14F-4D97-AF65-F5344CB8AC3E}">

</xml_diff>